<commit_message>
cours S8_P4 + PowerPoints S7/S8
</commit_message>
<xml_diff>
--- a/Cours_Python_IA.pptx
+++ b/Cours_Python_IA.pptx
@@ -46,9 +46,11 @@
     <p:sldId id="294" r:id="rId40"/>
     <p:sldId id="295" r:id="rId41"/>
     <p:sldId id="296" r:id="rId42"/>
+    <p:sldId id="297" r:id="rId43"/>
+    <p:sldId id="298" r:id="rId44"/>
   </p:sldIdLst>
   <p:notesMasterIdLst>
-    <p:notesMasterId r:id="rId43"/>
+    <p:notesMasterId r:id="rId45"/>
   </p:notesMasterIdLst>
   <p:sldSz cx="9144000" cy="5143500"/>
   <p:notesSz cx="5143500" cy="9144000"/>
@@ -2785,6 +2787,481 @@
 </c:chartSpace>
 </file>
 
+<file path=ppt/charts/chart8.xml><?xml version="1.0" encoding="utf-8"?>
+<c:chartSpace xmlns:c="http://schemas.openxmlformats.org/drawingml/2006/chart" xmlns:a="http://schemas.openxmlformats.org/drawingml/2006/main" xmlns:r="http://schemas.openxmlformats.org/officeDocument/2006/relationships">
+  <c:date1904 val="0"/>
+  <c:roundedCorners val="1"/>
+  <c:chart>
+    <c:title>
+      <c:tx>
+        <c:rich>
+          <a:bodyPr/>
+          <a:lstStyle/>
+          <a:p>
+            <a:pPr>
+              <a:defRPr sz="1100" b="0" i="0" u="none" strike="noStrike">
+                <a:solidFill>
+                  <a:srgbClr val="1E2761"/>
+                </a:solidFill>
+                <a:latin typeface="Arial"/>
+              </a:defRPr>
+            </a:pPr>
+            <a:r>
+              <a:rPr sz="1100" b="0" i="0" u="none" strike="noStrike">
+                <a:solidFill>
+                  <a:srgbClr val="1E2761"/>
+                </a:solidFill>
+                <a:latin typeface="Arial"/>
+              </a:rPr>
+              <a:t>ROC : détections (TPR) vs fausses alertes (FPR)</a:t>
+            </a:r>
+          </a:p>
+        </c:rich>
+      </c:tx>
+      <c:layout/>
+      <c:overlay val="0"/>
+    </c:title>
+    <c:autoTitleDeleted val="0"/>
+    <c:plotArea>
+      <c:layout/>
+      <c:lineChart>
+        <c:varyColors val="0"/>
+        <c:ser>
+          <c:idx val="0"/>
+          <c:order val="0"/>
+          <c:tx>
+            <c:strRef>
+              <c:f>Sheet1!$B$1</c:f>
+              <c:strCache>
+                <c:ptCount val="1"/>
+                <c:pt idx="0">
+                  <c:v>Modèle (AUC ≈ 0.94)</c:v>
+                </c:pt>
+              </c:strCache>
+            </c:strRef>
+          </c:tx>
+          <c:spPr>
+            <a:solidFill>
+              <a:srgbClr val="02C39A"/>
+            </a:solidFill>
+            <a:ln w="31750" cap="flat">
+              <a:solidFill>
+                <a:srgbClr val="02C39A"/>
+              </a:solidFill>
+              <a:prstDash val="solid"/>
+              <a:round/>
+            </a:ln>
+            <a:effectLst/>
+          </c:spPr>
+          <c:invertIfNegative val="0"/>
+          <c:dLbls>
+            <c:numFmt formatCode="#,##0" sourceLinked="0"/>
+            <c:txPr>
+              <a:bodyPr/>
+              <a:lstStyle/>
+              <a:p>
+                <a:pPr>
+                  <a:defRPr b="0" i="0" strike="noStrike" sz="1200" u="none">
+                    <a:solidFill>
+                      <a:srgbClr val="000000"/>
+                    </a:solidFill>
+                    <a:latin typeface="Arial"/>
+                  </a:defRPr>
+                </a:pPr>
+              </a:p>
+            </c:txPr>
+            <c:showLegendKey val="0"/>
+            <c:showVal val="0"/>
+            <c:showCatName val="0"/>
+            <c:showSerName val="0"/>
+            <c:showPercent val="0"/>
+            <c:showBubbleSize val="0"/>
+            <c:showLeaderLines val="0"/>
+          </c:dLbls>
+          <c:marker>
+            <c:symbol val="none"/>
+            <c:size val="6"/>
+            <c:spPr>
+              <a:solidFill>
+                <a:srgbClr val="02C39A"/>
+              </a:solidFill>
+              <a:ln w="9525" cap="flat">
+                <a:solidFill>
+                  <a:srgbClr val="02C39A"/>
+                </a:solidFill>
+                <a:prstDash val="solid"/>
+                <a:round/>
+              </a:ln>
+              <a:effectLst/>
+            </c:spPr>
+          </c:marker>
+          <c:cat>
+            <c:multiLvlStrRef>
+              <c:f>Sheet1!$A$2:$A$9</c:f>
+              <c:multiLvlStrCache>
+                <c:ptCount val="8"/>
+                <c:lvl>
+                  <c:pt idx="0">
+                    <c:v>0</c:v>
+                  </c:pt>
+                  <c:pt idx="1">
+                    <c:v>0.05</c:v>
+                  </c:pt>
+                  <c:pt idx="2">
+                    <c:v>0.1</c:v>
+                  </c:pt>
+                  <c:pt idx="3">
+                    <c:v>0.2</c:v>
+                  </c:pt>
+                  <c:pt idx="4">
+                    <c:v>0.3</c:v>
+                  </c:pt>
+                  <c:pt idx="5">
+                    <c:v>0.5</c:v>
+                  </c:pt>
+                  <c:pt idx="6">
+                    <c:v>0.7</c:v>
+                  </c:pt>
+                  <c:pt idx="7">
+                    <c:v>1</c:v>
+                  </c:pt>
+                </c:lvl>
+              </c:multiLvlStrCache>
+            </c:multiLvlStrRef>
+          </c:cat>
+          <c:val>
+            <c:numRef>
+              <c:f>Sheet1!$B$2:$B$9</c:f>
+              <c:numCache>
+                <c:formatCode>General</c:formatCode>
+                <c:ptCount val="8"/>
+                <c:pt idx="0">
+                  <c:v>0</c:v>
+                </c:pt>
+                <c:pt idx="1">
+                  <c:v>0.62</c:v>
+                </c:pt>
+                <c:pt idx="2">
+                  <c:v>0.74</c:v>
+                </c:pt>
+                <c:pt idx="3">
+                  <c:v>0.85</c:v>
+                </c:pt>
+                <c:pt idx="4">
+                  <c:v>0.91</c:v>
+                </c:pt>
+                <c:pt idx="5">
+                  <c:v>0.96</c:v>
+                </c:pt>
+                <c:pt idx="6">
+                  <c:v>0.99</c:v>
+                </c:pt>
+                <c:pt idx="7">
+                  <c:v>1</c:v>
+                </c:pt>
+              </c:numCache>
+            </c:numRef>
+          </c:val>
+          <c:smooth val="1"/>
+        </c:ser>
+        <c:ser>
+          <c:idx val="1"/>
+          <c:order val="1"/>
+          <c:tx>
+            <c:strRef>
+              <c:f>Sheet1!$C$1</c:f>
+              <c:strCache>
+                <c:ptCount val="1"/>
+                <c:pt idx="0">
+                  <c:v>Hasard (AUC = 0.5)</c:v>
+                </c:pt>
+              </c:strCache>
+            </c:strRef>
+          </c:tx>
+          <c:spPr>
+            <a:solidFill>
+              <a:srgbClr val="5A6B8C"/>
+            </a:solidFill>
+            <a:ln w="31750" cap="flat">
+              <a:solidFill>
+                <a:srgbClr val="5A6B8C"/>
+              </a:solidFill>
+              <a:prstDash val="solid"/>
+              <a:round/>
+            </a:ln>
+            <a:effectLst/>
+          </c:spPr>
+          <c:invertIfNegative val="0"/>
+          <c:dLbls>
+            <c:numFmt formatCode="#,##0" sourceLinked="0"/>
+            <c:txPr>
+              <a:bodyPr/>
+              <a:lstStyle/>
+              <a:p>
+                <a:pPr>
+                  <a:defRPr b="0" i="0" strike="noStrike" sz="1200" u="none">
+                    <a:solidFill>
+                      <a:srgbClr val="000000"/>
+                    </a:solidFill>
+                    <a:latin typeface="Arial"/>
+                  </a:defRPr>
+                </a:pPr>
+              </a:p>
+            </c:txPr>
+            <c:showLegendKey val="0"/>
+            <c:showVal val="0"/>
+            <c:showCatName val="0"/>
+            <c:showSerName val="0"/>
+            <c:showPercent val="0"/>
+            <c:showBubbleSize val="0"/>
+            <c:showLeaderLines val="0"/>
+          </c:dLbls>
+          <c:marker>
+            <c:symbol val="none"/>
+            <c:size val="6"/>
+            <c:spPr>
+              <a:solidFill>
+                <a:srgbClr val="5A6B8C"/>
+              </a:solidFill>
+              <a:ln w="9525" cap="flat">
+                <a:solidFill>
+                  <a:srgbClr val="5A6B8C"/>
+                </a:solidFill>
+                <a:prstDash val="solid"/>
+                <a:round/>
+              </a:ln>
+              <a:effectLst/>
+            </c:spPr>
+          </c:marker>
+          <c:cat>
+            <c:multiLvlStrRef>
+              <c:f>Sheet1!$A$2:$A$9</c:f>
+              <c:multiLvlStrCache>
+                <c:ptCount val="8"/>
+                <c:lvl>
+                  <c:pt idx="0">
+                    <c:v>0</c:v>
+                  </c:pt>
+                  <c:pt idx="1">
+                    <c:v>0.05</c:v>
+                  </c:pt>
+                  <c:pt idx="2">
+                    <c:v>0.1</c:v>
+                  </c:pt>
+                  <c:pt idx="3">
+                    <c:v>0.2</c:v>
+                  </c:pt>
+                  <c:pt idx="4">
+                    <c:v>0.3</c:v>
+                  </c:pt>
+                  <c:pt idx="5">
+                    <c:v>0.5</c:v>
+                  </c:pt>
+                  <c:pt idx="6">
+                    <c:v>0.7</c:v>
+                  </c:pt>
+                  <c:pt idx="7">
+                    <c:v>1</c:v>
+                  </c:pt>
+                </c:lvl>
+              </c:multiLvlStrCache>
+            </c:multiLvlStrRef>
+          </c:cat>
+          <c:val>
+            <c:numRef>
+              <c:f>Sheet1!$C$2:$C$9</c:f>
+              <c:numCache>
+                <c:formatCode>General</c:formatCode>
+                <c:ptCount val="8"/>
+                <c:pt idx="0">
+                  <c:v>0</c:v>
+                </c:pt>
+                <c:pt idx="1">
+                  <c:v>0.05</c:v>
+                </c:pt>
+                <c:pt idx="2">
+                  <c:v>0.1</c:v>
+                </c:pt>
+                <c:pt idx="3">
+                  <c:v>0.2</c:v>
+                </c:pt>
+                <c:pt idx="4">
+                  <c:v>0.3</c:v>
+                </c:pt>
+                <c:pt idx="5">
+                  <c:v>0.5</c:v>
+                </c:pt>
+                <c:pt idx="6">
+                  <c:v>0.7</c:v>
+                </c:pt>
+                <c:pt idx="7">
+                  <c:v>1</c:v>
+                </c:pt>
+              </c:numCache>
+            </c:numRef>
+          </c:val>
+          <c:smooth val="1"/>
+        </c:ser>
+        <c:dLbls>
+          <c:numFmt formatCode="#,##0" sourceLinked="0"/>
+          <c:txPr>
+            <a:bodyPr/>
+            <a:lstStyle/>
+            <a:p>
+              <a:pPr>
+                <a:defRPr b="0" i="0" strike="noStrike" sz="1200" u="none">
+                  <a:solidFill>
+                    <a:srgbClr val="000000"/>
+                  </a:solidFill>
+                  <a:latin typeface="Arial"/>
+                </a:defRPr>
+              </a:pPr>
+            </a:p>
+          </c:txPr>
+          <c:showLegendKey val="0"/>
+          <c:showVal val="0"/>
+          <c:showCatName val="0"/>
+          <c:showSerName val="0"/>
+          <c:showPercent val="0"/>
+          <c:showBubbleSize val="0"/>
+          <c:showLeaderLines val="0"/>
+        </c:dLbls>
+        <c:marker val="1"/>
+        <c:axId val="2094734554"/>
+        <c:axId val="2094734552"/>
+        <c:axId val="2094734556"/>
+      </c:lineChart>
+      <c:catAx>
+        <c:axId val="2094734554"/>
+        <c:scaling>
+          <c:orientation val="minMax"/>
+        </c:scaling>
+        <c:delete val="0"/>
+        <c:axPos val="b"/>
+        <c:numFmt formatCode="General" sourceLinked="1"/>
+        <c:majorTickMark val="out"/>
+        <c:minorTickMark val="none"/>
+        <c:tickLblPos val="low"/>
+        <c:spPr>
+          <a:ln w="12700" cap="flat">
+            <a:solidFill>
+              <a:srgbClr val="888888"/>
+            </a:solidFill>
+            <a:prstDash val="solid"/>
+            <a:round/>
+          </a:ln>
+        </c:spPr>
+        <c:txPr>
+          <a:bodyPr/>
+          <a:lstStyle/>
+          <a:p>
+            <a:pPr>
+              <a:defRPr sz="900" b="0" i="0" u="none" strike="noStrike">
+                <a:solidFill>
+                  <a:srgbClr val="5A6B8C"/>
+                </a:solidFill>
+                <a:latin typeface="Arial"/>
+              </a:defRPr>
+            </a:pPr>
+            <a:endParaRPr lang="en-US"/>
+          </a:p>
+        </c:txPr>
+        <c:crossAx val="2094734552"/>
+        <c:crosses val="autoZero"/>
+        <c:auto val="1"/>
+        <c:lblAlgn val="ctr"/>
+        <c:noMultiLvlLbl val="1"/>
+      </c:catAx>
+      <c:valAx>
+        <c:axId val="2094734552"/>
+        <c:scaling>
+          <c:orientation val="minMax"/>
+        </c:scaling>
+        <c:delete val="0"/>
+        <c:axPos val="l"/>
+        <c:majorGridlines>
+          <c:spPr>
+            <a:ln w="6350" cap="flat">
+              <a:solidFill>
+                <a:srgbClr val="E4EAF5"/>
+              </a:solidFill>
+              <a:prstDash val="solid"/>
+              <a:round/>
+            </a:ln>
+          </c:spPr>
+        </c:majorGridlines>
+        <c:numFmt formatCode="General" sourceLinked="0"/>
+        <c:majorTickMark val="out"/>
+        <c:minorTickMark val="none"/>
+        <c:tickLblPos val="nextTo"/>
+        <c:spPr>
+          <a:ln w="12700" cap="flat">
+            <a:solidFill>
+              <a:srgbClr val="888888"/>
+            </a:solidFill>
+            <a:prstDash val="solid"/>
+            <a:round/>
+          </a:ln>
+        </c:spPr>
+        <c:txPr>
+          <a:bodyPr/>
+          <a:lstStyle/>
+          <a:p>
+            <a:pPr>
+              <a:defRPr sz="900" b="0" i="0" u="none" strike="noStrike">
+                <a:solidFill>
+                  <a:srgbClr val="5A6B8C"/>
+                </a:solidFill>
+                <a:latin typeface="Arial"/>
+              </a:defRPr>
+            </a:pPr>
+            <a:endParaRPr lang="en-US"/>
+          </a:p>
+        </c:txPr>
+        <c:crossAx val="2094734554"/>
+        <c:crosses val="autoZero"/>
+        <c:crossBetween val="between"/>
+      </c:valAx>
+      <c:spPr>
+        <a:noFill/>
+        <a:ln>
+          <a:noFill/>
+        </a:ln>
+        <a:effectLst/>
+      </c:spPr>
+    </c:plotArea>
+    <c:legend>
+      <c:legendPos val="b"/>
+      <c:overlay val="0"/>
+      <c:txPr>
+        <a:bodyPr/>
+        <a:lstStyle/>
+        <a:p>
+          <a:pPr>
+            <a:defRPr sz="900">      </a:defRPr>
+          </a:pPr>
+          <a:endParaRPr lang="en-US"/>
+        </a:p>
+      </c:txPr>
+    </c:legend>
+    <c:plotVisOnly val="1"/>
+    <c:dispBlanksAs val="span"/>
+  </c:chart>
+  <c:spPr>
+    <a:solidFill>
+      <a:srgbClr val="FFFFFF"/>
+    </a:solidFill>
+    <a:ln>
+      <a:noFill/>
+    </a:ln>
+    <a:effectLst/>
+  </c:spPr>
+  <c:externalData r:id="rId1">
+    <c:autoUpdate val="0"/>
+  </c:externalData>
+</c:chartSpace>
+</file>
+
 <file path=ppt/notesMasters/notesMaster1.xml><?xml version="1.0" encoding="utf-8"?>
 <p:notesMaster xmlns:a="http://schemas.openxmlformats.org/drawingml/2006/main" xmlns:r="http://schemas.openxmlformats.org/officeDocument/2006/relationships" xmlns:p="http://schemas.openxmlformats.org/presentationml/2006/main">
   <p:cSld>
@@ -6284,6 +6761,182 @@
             <a:fld id="{F7021451-1387-4CA6-816F-3879F97B5CBC}" type="slidenum">
               <a:rPr lang="en-US"/>
               <a:t>41</a:t>
+            </a:fld>
+            <a:endParaRPr lang="en-US"/>
+          </a:p>
+        </p:txBody>
+      </p:sp>
+    </p:spTree>
+    <p:extLst>
+      <p:ext uri="{BB962C8B-B14F-4D97-AF65-F5344CB8AC3E}">
+        <p14:creationId xmlns:p14="http://schemas.microsoft.com/office/powerpoint/2010/main" val="1024086991"/>
+      </p:ext>
+    </p:extLst>
+  </p:cSld>
+  <p:clrMapOvr>
+    <a:masterClrMapping/>
+  </p:clrMapOvr>
+</p:notes>
+</file>
+
+<file path=ppt/notesSlides/notesSlide42.xml><?xml version="1.0" encoding="utf-8"?>
+<p:notes xmlns:a="http://schemas.openxmlformats.org/drawingml/2006/main" xmlns:r="http://schemas.openxmlformats.org/officeDocument/2006/relationships" xmlns:p="http://schemas.openxmlformats.org/presentationml/2006/main">
+  <p:cSld>
+    <p:spTree>
+      <p:nvGrpSpPr>
+        <p:cNvPr id="1" name=""/>
+        <p:cNvGrpSpPr/>
+        <p:nvPr/>
+      </p:nvGrpSpPr>
+      <p:grpSpPr>
+        <a:xfrm>
+          <a:off x="0" y="0"/>
+          <a:ext cx="0" cy="0"/>
+          <a:chOff x="0" y="0"/>
+          <a:chExt cx="0" cy="0"/>
+        </a:xfrm>
+      </p:grpSpPr>
+      <p:sp>
+        <p:nvSpPr>
+          <p:cNvPr id="2" name="Slide Image Placeholder 1"/>
+          <p:cNvSpPr>
+            <a:spLocks noGrp="1" noRot="1" noChangeAspect="1"/>
+          </p:cNvSpPr>
+          <p:nvPr>
+            <p:ph type="sldImg"/>
+          </p:nvPr>
+        </p:nvSpPr>
+        <p:spPr/>
+      </p:sp>
+      <p:sp>
+        <p:nvSpPr>
+          <p:cNvPr id="3" name="Notes Placeholder 2"/>
+          <p:cNvSpPr>
+            <a:spLocks noGrp="1"/>
+          </p:cNvSpPr>
+          <p:nvPr>
+            <p:ph type="body" idx="1"/>
+          </p:nvPr>
+        </p:nvSpPr>
+        <p:spPr/>
+        <p:txBody>
+          <a:bodyPr/>
+          <a:lstStyle/>
+          <a:p>
+            <a:r>
+              <a:rPr lang="en-US" dirty="0"/>
+              <a:t/>
+            </a:r>
+            <a:endParaRPr lang="en-US" dirty="0"/>
+          </a:p>
+        </p:txBody>
+      </p:sp>
+      <p:sp>
+        <p:nvSpPr>
+          <p:cNvPr id="4" name="Slide Number Placeholder 3"/>
+          <p:cNvSpPr>
+            <a:spLocks noGrp="1"/>
+          </p:cNvSpPr>
+          <p:nvPr>
+            <p:ph type="sldNum" sz="quarter" idx="10"/>
+          </p:nvPr>
+        </p:nvSpPr>
+        <p:spPr/>
+        <p:txBody>
+          <a:bodyPr/>
+          <a:lstStyle/>
+          <a:p>
+            <a:fld id="{F7021451-1387-4CA6-816F-3879F97B5CBC}" type="slidenum">
+              <a:rPr lang="en-US"/>
+              <a:t>42</a:t>
+            </a:fld>
+            <a:endParaRPr lang="en-US"/>
+          </a:p>
+        </p:txBody>
+      </p:sp>
+    </p:spTree>
+    <p:extLst>
+      <p:ext uri="{BB962C8B-B14F-4D97-AF65-F5344CB8AC3E}">
+        <p14:creationId xmlns:p14="http://schemas.microsoft.com/office/powerpoint/2010/main" val="1024086991"/>
+      </p:ext>
+    </p:extLst>
+  </p:cSld>
+  <p:clrMapOvr>
+    <a:masterClrMapping/>
+  </p:clrMapOvr>
+</p:notes>
+</file>
+
+<file path=ppt/notesSlides/notesSlide43.xml><?xml version="1.0" encoding="utf-8"?>
+<p:notes xmlns:a="http://schemas.openxmlformats.org/drawingml/2006/main" xmlns:r="http://schemas.openxmlformats.org/officeDocument/2006/relationships" xmlns:p="http://schemas.openxmlformats.org/presentationml/2006/main">
+  <p:cSld>
+    <p:spTree>
+      <p:nvGrpSpPr>
+        <p:cNvPr id="1" name=""/>
+        <p:cNvGrpSpPr/>
+        <p:nvPr/>
+      </p:nvGrpSpPr>
+      <p:grpSpPr>
+        <a:xfrm>
+          <a:off x="0" y="0"/>
+          <a:ext cx="0" cy="0"/>
+          <a:chOff x="0" y="0"/>
+          <a:chExt cx="0" cy="0"/>
+        </a:xfrm>
+      </p:grpSpPr>
+      <p:sp>
+        <p:nvSpPr>
+          <p:cNvPr id="2" name="Slide Image Placeholder 1"/>
+          <p:cNvSpPr>
+            <a:spLocks noGrp="1" noRot="1" noChangeAspect="1"/>
+          </p:cNvSpPr>
+          <p:nvPr>
+            <p:ph type="sldImg"/>
+          </p:nvPr>
+        </p:nvSpPr>
+        <p:spPr/>
+      </p:sp>
+      <p:sp>
+        <p:nvSpPr>
+          <p:cNvPr id="3" name="Notes Placeholder 2"/>
+          <p:cNvSpPr>
+            <a:spLocks noGrp="1"/>
+          </p:cNvSpPr>
+          <p:nvPr>
+            <p:ph type="body" idx="1"/>
+          </p:nvPr>
+        </p:nvSpPr>
+        <p:spPr/>
+        <p:txBody>
+          <a:bodyPr/>
+          <a:lstStyle/>
+          <a:p>
+            <a:r>
+              <a:rPr lang="en-US" dirty="0"/>
+              <a:t/>
+            </a:r>
+            <a:endParaRPr lang="en-US" dirty="0"/>
+          </a:p>
+        </p:txBody>
+      </p:sp>
+      <p:sp>
+        <p:nvSpPr>
+          <p:cNvPr id="4" name="Slide Number Placeholder 3"/>
+          <p:cNvSpPr>
+            <a:spLocks noGrp="1"/>
+          </p:cNvSpPr>
+          <p:nvPr>
+            <p:ph type="sldNum" sz="quarter" idx="10"/>
+          </p:nvPr>
+        </p:nvSpPr>
+        <p:spPr/>
+        <p:txBody>
+          <a:bodyPr/>
+          <a:lstStyle/>
+          <a:p>
+            <a:fld id="{F7021451-1387-4CA6-816F-3879F97B5CBC}" type="slidenum">
+              <a:rPr lang="en-US"/>
+              <a:t>43</a:t>
             </a:fld>
             <a:endParaRPr lang="en-US"/>
           </a:p>
@@ -7649,7 +8302,7 @@
                 <a:ea typeface="Calibri" pitchFamily="34" charset="-122"/>
                 <a:cs typeface="Calibri" pitchFamily="34" charset="-120"/>
               </a:rPr>
-              <a:t>Machine Learning (S1 → S6).</a:t>
+              <a:t>Machine Learning (S1 → S8).</a:t>
             </a:r>
             <a:endParaRPr lang="en-US" sz="1350" dirty="0"/>
           </a:p>
@@ -20894,6 +21547,110 @@
               </a:rPr>
               <a:t>— forêts aléatoires, GridSearch, élagage, SHAP</a:t>
             </a:r>
+            <a:pPr indent="0" marL="0">
+              <a:lnSpc>
+                <a:spcPct val="135000"/>
+              </a:lnSpc>
+              <a:buNone/>
+            </a:pPr>
+            <a:r>
+              <a:rPr lang="en-US" sz="1150" dirty="0">
+                <a:solidFill>
+                  <a:srgbClr val="2A3550"/>
+                </a:solidFill>
+                <a:latin typeface="Calibri" pitchFamily="34" charset="0"/>
+                <a:ea typeface="Calibri" pitchFamily="34" charset="-122"/>
+                <a:cs typeface="Calibri" pitchFamily="34" charset="-120"/>
+              </a:rPr>
+              <a:t>
+</a:t>
+            </a:r>
+            <a:pPr indent="0" marL="0">
+              <a:lnSpc>
+                <a:spcPct val="135000"/>
+              </a:lnSpc>
+              <a:buNone/>
+            </a:pPr>
+            <a:r>
+              <a:rPr lang="en-US" sz="1150" b="1" dirty="0">
+                <a:solidFill>
+                  <a:srgbClr val="1E2761"/>
+                </a:solidFill>
+                <a:latin typeface="Calibri" pitchFamily="34" charset="0"/>
+                <a:ea typeface="Calibri" pitchFamily="34" charset="-122"/>
+                <a:cs typeface="Calibri" pitchFamily="34" charset="-120"/>
+              </a:rPr>
+              <a:t>S7 </a:t>
+            </a:r>
+            <a:pPr indent="0" marL="0">
+              <a:lnSpc>
+                <a:spcPct val="135000"/>
+              </a:lnSpc>
+              <a:buNone/>
+            </a:pPr>
+            <a:r>
+              <a:rPr lang="en-US" sz="1150" dirty="0">
+                <a:solidFill>
+                  <a:srgbClr val="2A3550"/>
+                </a:solidFill>
+                <a:latin typeface="Calibri" pitchFamily="34" charset="0"/>
+                <a:ea typeface="Calibri" pitchFamily="34" charset="-122"/>
+                <a:cs typeface="Calibri" pitchFamily="34" charset="-120"/>
+              </a:rPr>
+              <a:t>— Gradient Boosting, courbe ROC &amp; AUC, crédit</a:t>
+            </a:r>
+            <a:pPr indent="0" marL="0">
+              <a:lnSpc>
+                <a:spcPct val="135000"/>
+              </a:lnSpc>
+              <a:buNone/>
+            </a:pPr>
+            <a:r>
+              <a:rPr lang="en-US" sz="1150" dirty="0">
+                <a:solidFill>
+                  <a:srgbClr val="2A3550"/>
+                </a:solidFill>
+                <a:latin typeface="Calibri" pitchFamily="34" charset="0"/>
+                <a:ea typeface="Calibri" pitchFamily="34" charset="-122"/>
+                <a:cs typeface="Calibri" pitchFamily="34" charset="-120"/>
+              </a:rPr>
+              <a:t>
+</a:t>
+            </a:r>
+            <a:pPr indent="0" marL="0">
+              <a:lnSpc>
+                <a:spcPct val="135000"/>
+              </a:lnSpc>
+              <a:buNone/>
+            </a:pPr>
+            <a:r>
+              <a:rPr lang="en-US" sz="1150" b="1" dirty="0">
+                <a:solidFill>
+                  <a:srgbClr val="1E2761"/>
+                </a:solidFill>
+                <a:latin typeface="Calibri" pitchFamily="34" charset="0"/>
+                <a:ea typeface="Calibri" pitchFamily="34" charset="-122"/>
+                <a:cs typeface="Calibri" pitchFamily="34" charset="-120"/>
+              </a:rPr>
+              <a:t>S8 </a:t>
+            </a:r>
+            <a:pPr indent="0" marL="0">
+              <a:lnSpc>
+                <a:spcPct val="135000"/>
+              </a:lnSpc>
+              <a:buNone/>
+            </a:pPr>
+            <a:r>
+              <a:rPr lang="en-US" sz="1150" dirty="0">
+                <a:solidFill>
+                  <a:srgbClr val="2A3550"/>
+                </a:solidFill>
+                <a:latin typeface="Calibri" pitchFamily="34" charset="0"/>
+                <a:ea typeface="Calibri" pitchFamily="34" charset="-122"/>
+                <a:cs typeface="Calibri" pitchFamily="34" charset="-120"/>
+              </a:rPr>
+              <a:t>— clustering : KMeans, DBSCAN, PCA &amp; t-SNE</a:t>
+            </a:r>
             <a:endParaRPr lang="en-US" sz="1150" dirty="0"/>
           </a:p>
         </p:txBody>
@@ -21773,7 +22530,7 @@
                 <a:ea typeface="Calibri" pitchFamily="34" charset="-122"/>
                 <a:cs typeface="Calibri" pitchFamily="34" charset="-120"/>
               </a:rPr>
-              <a:t>KNN, arbres de décision, forêts — les notebooks S1 à S6 du dossier Cours_IA.</a:t>
+              <a:t>KNN, arbres de décision, forêts — les notebooks S1 à S8 du dossier Cours_IA.</a:t>
             </a:r>
             <a:endParaRPr lang="en-US" sz="1350" dirty="0"/>
           </a:p>
@@ -38135,7 +38892,7 @@
                 <a:ea typeface="Calibri" pitchFamily="34" charset="-122"/>
                 <a:cs typeface="Calibri" pitchFamily="34" charset="-120"/>
               </a:rPr>
-              <a:t>LE MUR DE LA HONTE (ON A TOUS FAIT CES ERREURS)</a:t>
+              <a:t>S7_P1, S7_P2 · LE RISQUE DE CRÉDIT</a:t>
             </a:r>
             <a:endParaRPr lang="en-US" sz="1100" dirty="0"/>
           </a:p>
@@ -38174,7 +38931,7 @@
                 <a:ea typeface="Calibri" pitchFamily="34" charset="-122"/>
                 <a:cs typeface="Calibri" pitchFamily="34" charset="-120"/>
               </a:rPr>
-              <a:t>Les 8 pièges célèbres du cours 🏆</a:t>
+              <a:t>S7 : Gradient Boosting, courbe ROC &amp; AUC</a:t>
             </a:r>
             <a:endParaRPr lang="en-US" sz="2700" dirty="0"/>
           </a:p>
@@ -38189,11 +38946,11 @@
         <p:spPr>
           <a:xfrm>
             <a:off x="457200" y="1188720"/>
-            <a:ext cx="4041648" cy="804672"/>
+            <a:ext cx="4206240" cy="1463040"/>
           </a:xfrm>
           <a:prstGeom prst="roundRect">
             <a:avLst>
-              <a:gd name="adj" fmla="val 6818"/>
+              <a:gd name="adj" fmla="val 3750"/>
             </a:avLst>
           </a:prstGeom>
           <a:solidFill>
@@ -38211,23 +38968,42 @@
       </p:sp>
       <p:sp>
         <p:nvSpPr>
-          <p:cNvPr id="5" name="Shape 3"/>
-          <p:cNvSpPr/>
-          <p:nvPr/>
-        </p:nvSpPr>
-        <p:spPr>
-          <a:xfrm>
-            <a:off x="566928" y="1426464"/>
-            <a:ext cx="329184" cy="329184"/>
-          </a:xfrm>
-          <a:prstGeom prst="ellipse">
-            <a:avLst/>
-          </a:prstGeom>
-          <a:solidFill>
-            <a:srgbClr val="D64550"/>
-          </a:solidFill>
-          <a:ln/>
-        </p:spPr>
+          <p:cNvPr id="5" name="Text 3"/>
+          <p:cNvSpPr/>
+          <p:nvPr/>
+        </p:nvSpPr>
+        <p:spPr>
+          <a:xfrm>
+            <a:off x="603504" y="1298448"/>
+            <a:ext cx="3913632" cy="274320"/>
+          </a:xfrm>
+          <a:prstGeom prst="rect">
+            <a:avLst/>
+          </a:prstGeom>
+          <a:noFill/>
+          <a:ln/>
+        </p:spPr>
+        <p:txBody>
+          <a:bodyPr wrap="square" lIns="0" tIns="0" rIns="0" bIns="0" rtlCol="0" anchor="ctr"/>
+          <a:lstStyle/>
+          <a:p>
+            <a:pPr indent="0" marL="0">
+              <a:buNone/>
+            </a:pPr>
+            <a:r>
+              <a:rPr lang="en-US" sz="1250" b="1" dirty="0">
+                <a:solidFill>
+                  <a:srgbClr val="1E2761"/>
+                </a:solidFill>
+                <a:latin typeface="Calibri" pitchFamily="34" charset="0"/>
+                <a:ea typeface="Calibri" pitchFamily="34" charset="-122"/>
+                <a:cs typeface="Calibri" pitchFamily="34" charset="-120"/>
+              </a:rPr>
+              <a:t>🚀 Gradient Boosting : les arbres qui se corrigent</a:t>
+            </a:r>
+            <a:endParaRPr lang="en-US" sz="1250" dirty="0"/>
+          </a:p>
+        </p:txBody>
       </p:sp>
       <p:sp>
         <p:nvSpPr>
@@ -38237,8 +39013,8 @@
         </p:nvSpPr>
         <p:spPr>
           <a:xfrm>
-            <a:off x="566928" y="1417320"/>
-            <a:ext cx="329184" cy="329184"/>
+            <a:off x="603504" y="1591056"/>
+            <a:ext cx="3913632" cy="950976"/>
           </a:xfrm>
           <a:prstGeom prst="rect">
             <a:avLst/>
@@ -38247,76 +39023,17 @@
           <a:ln/>
         </p:spPr>
         <p:txBody>
-          <a:bodyPr wrap="square" lIns="0" tIns="0" rIns="0" bIns="0" rtlCol="0" anchor="ctr"/>
-          <a:lstStyle/>
-          <a:p>
-            <a:pPr algn="ctr" indent="0" marL="0">
-              <a:buNone/>
-            </a:pPr>
-            <a:r>
-              <a:rPr lang="en-US" sz="1300" b="1" dirty="0">
-                <a:solidFill>
-                  <a:srgbClr val="FFFFFF"/>
-                </a:solidFill>
-                <a:latin typeface="Calibri" pitchFamily="34" charset="0"/>
-                <a:ea typeface="Calibri" pitchFamily="34" charset="-122"/>
-                <a:cs typeface="Calibri" pitchFamily="34" charset="-120"/>
-              </a:rPr>
-              <a:t>1</a:t>
-            </a:r>
-            <a:endParaRPr lang="en-US" sz="1300" dirty="0"/>
-          </a:p>
-        </p:txBody>
-      </p:sp>
-      <p:sp>
-        <p:nvSpPr>
-          <p:cNvPr id="7" name="Text 5"/>
-          <p:cNvSpPr/>
-          <p:nvPr/>
-        </p:nvSpPr>
-        <p:spPr>
-          <a:xfrm>
-            <a:off x="1005840" y="1261872"/>
-            <a:ext cx="3401568" cy="685800"/>
-          </a:xfrm>
-          <a:prstGeom prst="rect">
-            <a:avLst/>
-          </a:prstGeom>
-          <a:noFill/>
-          <a:ln/>
-        </p:spPr>
-        <p:txBody>
           <a:bodyPr wrap="square" lIns="0" tIns="0" rIns="0" bIns="0" rtlCol="0" anchor="t"/>
           <a:lstStyle/>
           <a:p>
             <a:pPr indent="0" marL="0">
               <a:lnSpc>
-                <a:spcPct val="105000"/>
-              </a:lnSpc>
-              <a:buNone/>
-            </a:pPr>
-            <a:r>
-              <a:rPr lang="en-US" sz="950" b="1" dirty="0">
-                <a:solidFill>
-                  <a:srgbClr val="1E2761"/>
-                </a:solidFill>
-                <a:latin typeface="Courier New" pitchFamily="34" charset="0"/>
-                <a:ea typeface="Courier New" pitchFamily="34" charset="-122"/>
-                <a:cs typeface="Courier New" pitchFamily="34" charset="-120"/>
-              </a:rPr>
-              <a:t>fit(X_test, y_test)</a:t>
-            </a:r>
-            <a:endParaRPr lang="en-US" sz="950" dirty="0"/>
-          </a:p>
-          <a:p>
-            <a:pPr indent="0" marL="0">
-              <a:lnSpc>
-                <a:spcPct val="105000"/>
-              </a:lnSpc>
-              <a:buNone/>
-            </a:pPr>
-            <a:r>
-              <a:rPr lang="en-US" sz="900" dirty="0">
+                <a:spcPct val="106000"/>
+              </a:lnSpc>
+              <a:buNone/>
+            </a:pPr>
+            <a:r>
+              <a:rPr lang="en-US" sz="1050" dirty="0">
                 <a:solidFill>
                   <a:srgbClr val="2A3550"/>
                 </a:solidFill>
@@ -38324,26 +39041,46 @@
                 <a:ea typeface="Calibri" pitchFamily="34" charset="-122"/>
                 <a:cs typeface="Calibri" pitchFamily="34" charset="-120"/>
               </a:rPr>
-              <a:t>entraîné sur le test = l'élève avec les corrigés (S2_P3)</a:t>
-            </a:r>
-            <a:endParaRPr lang="en-US" sz="950" dirty="0"/>
-          </a:p>
-        </p:txBody>
-      </p:sp>
-      <p:sp>
-        <p:nvSpPr>
-          <p:cNvPr id="8" name="Shape 6"/>
-          <p:cNvSpPr/>
-          <p:nvPr/>
-        </p:nvSpPr>
-        <p:spPr>
-          <a:xfrm>
-            <a:off x="4681728" y="1188720"/>
-            <a:ext cx="4041648" cy="804672"/>
+              <a:t>Contrairement à la forêt (parallèle), le boosting construit les arbres L'UN APRÈS L'AUTRE — chacun corrige les erreurs du précédent.</a:t>
+            </a:r>
+            <a:endParaRPr lang="en-US" sz="1050" dirty="0"/>
+          </a:p>
+          <a:p>
+            <a:pPr indent="0" marL="0">
+              <a:lnSpc>
+                <a:spcPct val="106000"/>
+              </a:lnSpc>
+              <a:buNone/>
+            </a:pPr>
+            <a:r>
+              <a:rPr lang="en-US" sz="1050" b="1" dirty="0">
+                <a:solidFill>
+                  <a:srgbClr val="2A3550"/>
+                </a:solidFill>
+                <a:latin typeface="Calibri" pitchFamily="34" charset="0"/>
+                <a:ea typeface="Calibri" pitchFamily="34" charset="-122"/>
+                <a:cs typeface="Calibri" pitchFamily="34" charset="-120"/>
+              </a:rPr>
+              <a:t>Règle d'or : des arbres FAIBLES (max_depth 2-5) ! Un depth=30 en boosting = 27 minutes de calcul pour rien.</a:t>
+            </a:r>
+            <a:endParaRPr lang="en-US" sz="1050" dirty="0"/>
+          </a:p>
+        </p:txBody>
+      </p:sp>
+      <p:sp>
+        <p:nvSpPr>
+          <p:cNvPr id="7" name="Shape 5"/>
+          <p:cNvSpPr/>
+          <p:nvPr/>
+        </p:nvSpPr>
+        <p:spPr>
+          <a:xfrm>
+            <a:off x="457200" y="2834640"/>
+            <a:ext cx="4206240" cy="960120"/>
           </a:xfrm>
           <a:prstGeom prst="roundRect">
             <a:avLst>
-              <a:gd name="adj" fmla="val 6818"/>
+              <a:gd name="adj" fmla="val 5714"/>
             </a:avLst>
           </a:prstGeom>
           <a:solidFill>
@@ -38361,34 +39098,14 @@
       </p:sp>
       <p:sp>
         <p:nvSpPr>
-          <p:cNvPr id="9" name="Shape 7"/>
-          <p:cNvSpPr/>
-          <p:nvPr/>
-        </p:nvSpPr>
-        <p:spPr>
-          <a:xfrm>
-            <a:off x="4791456" y="1426464"/>
-            <a:ext cx="329184" cy="329184"/>
-          </a:xfrm>
-          <a:prstGeom prst="ellipse">
-            <a:avLst/>
-          </a:prstGeom>
-          <a:solidFill>
-            <a:srgbClr val="D64550"/>
-          </a:solidFill>
-          <a:ln/>
-        </p:spPr>
-      </p:sp>
-      <p:sp>
-        <p:nvSpPr>
-          <p:cNvPr id="10" name="Text 8"/>
-          <p:cNvSpPr/>
-          <p:nvPr/>
-        </p:nvSpPr>
-        <p:spPr>
-          <a:xfrm>
-            <a:off x="4791456" y="1417320"/>
-            <a:ext cx="329184" cy="329184"/>
+          <p:cNvPr id="8" name="Text 6"/>
+          <p:cNvSpPr/>
+          <p:nvPr/>
+        </p:nvSpPr>
+        <p:spPr>
+          <a:xfrm>
+            <a:off x="603504" y="2944368"/>
+            <a:ext cx="3913632" cy="274320"/>
           </a:xfrm>
           <a:prstGeom prst="rect">
             <a:avLst/>
@@ -38400,34 +39117,34 @@
           <a:bodyPr wrap="square" lIns="0" tIns="0" rIns="0" bIns="0" rtlCol="0" anchor="ctr"/>
           <a:lstStyle/>
           <a:p>
-            <a:pPr algn="ctr" indent="0" marL="0">
-              <a:buNone/>
-            </a:pPr>
-            <a:r>
-              <a:rPr lang="en-US" sz="1300" b="1" dirty="0">
-                <a:solidFill>
-                  <a:srgbClr val="FFFFFF"/>
-                </a:solidFill>
-                <a:latin typeface="Calibri" pitchFamily="34" charset="0"/>
-                <a:ea typeface="Calibri" pitchFamily="34" charset="-122"/>
-                <a:cs typeface="Calibri" pitchFamily="34" charset="-120"/>
-              </a:rPr>
-              <a:t>2</a:t>
-            </a:r>
-            <a:endParaRPr lang="en-US" sz="1300" dirty="0"/>
-          </a:p>
-        </p:txBody>
-      </p:sp>
-      <p:sp>
-        <p:nvSpPr>
-          <p:cNvPr id="11" name="Text 9"/>
-          <p:cNvSpPr/>
-          <p:nvPr/>
-        </p:nvSpPr>
-        <p:spPr>
-          <a:xfrm>
-            <a:off x="5230368" y="1261872"/>
-            <a:ext cx="3401568" cy="685800"/>
+            <a:pPr indent="0" marL="0">
+              <a:buNone/>
+            </a:pPr>
+            <a:r>
+              <a:rPr lang="en-US" sz="1250" b="1" dirty="0">
+                <a:solidFill>
+                  <a:srgbClr val="1E2761"/>
+                </a:solidFill>
+                <a:latin typeface="Calibri" pitchFamily="34" charset="0"/>
+                <a:ea typeface="Calibri" pitchFamily="34" charset="-122"/>
+                <a:cs typeface="Calibri" pitchFamily="34" charset="-120"/>
+              </a:rPr>
+              <a:t>predict_proba : la probabilité derrière le 0/1</a:t>
+            </a:r>
+            <a:endParaRPr lang="en-US" sz="1250" dirty="0"/>
+          </a:p>
+        </p:txBody>
+      </p:sp>
+      <p:sp>
+        <p:nvSpPr>
+          <p:cNvPr id="9" name="Text 7"/>
+          <p:cNvSpPr/>
+          <p:nvPr/>
+        </p:nvSpPr>
+        <p:spPr>
+          <a:xfrm>
+            <a:off x="603504" y="3236976"/>
+            <a:ext cx="3913632" cy="448056"/>
           </a:xfrm>
           <a:prstGeom prst="rect">
             <a:avLst/>
@@ -38441,32 +39158,12 @@
           <a:p>
             <a:pPr indent="0" marL="0">
               <a:lnSpc>
-                <a:spcPct val="105000"/>
-              </a:lnSpc>
-              <a:buNone/>
-            </a:pPr>
-            <a:r>
-              <a:rPr lang="en-US" sz="950" b="1" dirty="0">
-                <a:solidFill>
-                  <a:srgbClr val="1E2761"/>
-                </a:solidFill>
-                <a:latin typeface="Courier New" pitchFamily="34" charset="0"/>
-                <a:ea typeface="Courier New" pitchFamily="34" charset="-122"/>
-                <a:cs typeface="Courier New" pitchFamily="34" charset="-120"/>
-              </a:rPr>
-              <a:t>classification_report(y_pred, y_test)</a:t>
-            </a:r>
-            <a:endParaRPr lang="en-US" sz="950" dirty="0"/>
-          </a:p>
-          <a:p>
-            <a:pPr indent="0" marL="0">
-              <a:lnSpc>
-                <a:spcPct val="105000"/>
-              </a:lnSpc>
-              <a:buNone/>
-            </a:pPr>
-            <a:r>
-              <a:rPr lang="en-US" sz="900" dirty="0">
+                <a:spcPct val="106000"/>
+              </a:lnSpc>
+              <a:buNone/>
+            </a:pPr>
+            <a:r>
+              <a:rPr lang="en-US" sz="1000" dirty="0">
                 <a:solidFill>
                   <a:srgbClr val="2A3550"/>
                 </a:solidFill>
@@ -38474,30 +39171,30 @@
                 <a:ea typeface="Calibri" pitchFamily="34" charset="-122"/>
                 <a:cs typeface="Calibri" pitchFamily="34" charset="-120"/>
               </a:rPr>
-              <a:t>ordre inversé → précision et rappel ÉCHANGÉS (S3)</a:t>
-            </a:r>
-            <a:endParaRPr lang="en-US" sz="950" dirty="0"/>
-          </a:p>
-        </p:txBody>
-      </p:sp>
-      <p:sp>
-        <p:nvSpPr>
-          <p:cNvPr id="12" name="Shape 10"/>
-          <p:cNvSpPr/>
-          <p:nvPr/>
-        </p:nvSpPr>
-        <p:spPr>
-          <a:xfrm>
-            <a:off x="457200" y="2103120"/>
-            <a:ext cx="4041648" cy="804672"/>
+              <a:t>Le modèle calcule P(défaut) ; le seuil 0.5 tranche. Mais ce seuil peut BOUGER — c'est tout l'objet de la courbe ROC.</a:t>
+            </a:r>
+            <a:endParaRPr lang="en-US" sz="1050" dirty="0"/>
+          </a:p>
+        </p:txBody>
+      </p:sp>
+      <p:sp>
+        <p:nvSpPr>
+          <p:cNvPr id="10" name="Shape 8"/>
+          <p:cNvSpPr/>
+          <p:nvPr/>
+        </p:nvSpPr>
+        <p:spPr>
+          <a:xfrm>
+            <a:off x="457200" y="3931920"/>
+            <a:ext cx="4206240" cy="868680"/>
           </a:xfrm>
           <a:prstGeom prst="roundRect">
             <a:avLst>
-              <a:gd name="adj" fmla="val 6818"/>
+              <a:gd name="adj" fmla="val 6316"/>
             </a:avLst>
           </a:prstGeom>
           <a:solidFill>
-            <a:srgbClr val="EEF4FE"/>
+            <a:srgbClr val="E9FAF5"/>
           </a:solidFill>
           <a:ln/>
           <a:effectLst>
@@ -38511,34 +39208,14 @@
       </p:sp>
       <p:sp>
         <p:nvSpPr>
-          <p:cNvPr id="13" name="Shape 11"/>
-          <p:cNvSpPr/>
-          <p:nvPr/>
-        </p:nvSpPr>
-        <p:spPr>
-          <a:xfrm>
-            <a:off x="566928" y="2340864"/>
-            <a:ext cx="329184" cy="329184"/>
-          </a:xfrm>
-          <a:prstGeom prst="ellipse">
-            <a:avLst/>
-          </a:prstGeom>
-          <a:solidFill>
-            <a:srgbClr val="D64550"/>
-          </a:solidFill>
-          <a:ln/>
-        </p:spPr>
-      </p:sp>
-      <p:sp>
-        <p:nvSpPr>
-          <p:cNvPr id="14" name="Text 12"/>
-          <p:cNvSpPr/>
-          <p:nvPr/>
-        </p:nvSpPr>
-        <p:spPr>
-          <a:xfrm>
-            <a:off x="566928" y="2331720"/>
-            <a:ext cx="329184" cy="329184"/>
+          <p:cNvPr id="11" name="Text 9"/>
+          <p:cNvSpPr/>
+          <p:nvPr/>
+        </p:nvSpPr>
+        <p:spPr>
+          <a:xfrm>
+            <a:off x="603504" y="4041648"/>
+            <a:ext cx="3913632" cy="274320"/>
           </a:xfrm>
           <a:prstGeom prst="rect">
             <a:avLst/>
@@ -38550,34 +39227,34 @@
           <a:bodyPr wrap="square" lIns="0" tIns="0" rIns="0" bIns="0" rtlCol="0" anchor="ctr"/>
           <a:lstStyle/>
           <a:p>
-            <a:pPr algn="ctr" indent="0" marL="0">
-              <a:buNone/>
-            </a:pPr>
-            <a:r>
-              <a:rPr lang="en-US" sz="1300" b="1" dirty="0">
-                <a:solidFill>
-                  <a:srgbClr val="FFFFFF"/>
-                </a:solidFill>
-                <a:latin typeface="Calibri" pitchFamily="34" charset="0"/>
-                <a:ea typeface="Calibri" pitchFamily="34" charset="-122"/>
-                <a:cs typeface="Calibri" pitchFamily="34" charset="-120"/>
-              </a:rPr>
-              <a:t>3</a:t>
-            </a:r>
-            <a:endParaRPr lang="en-US" sz="1300" dirty="0"/>
-          </a:p>
-        </p:txBody>
-      </p:sp>
-      <p:sp>
-        <p:nvSpPr>
-          <p:cNvPr id="15" name="Text 13"/>
-          <p:cNvSpPr/>
-          <p:nvPr/>
-        </p:nvSpPr>
-        <p:spPr>
-          <a:xfrm>
-            <a:off x="1005840" y="2176272"/>
-            <a:ext cx="3401568" cy="685800"/>
+            <a:pPr indent="0" marL="0">
+              <a:buNone/>
+            </a:pPr>
+            <a:r>
+              <a:rPr lang="en-US" sz="1250" b="1" dirty="0">
+                <a:solidFill>
+                  <a:srgbClr val="1E2761"/>
+                </a:solidFill>
+                <a:latin typeface="Calibri" pitchFamily="34" charset="0"/>
+                <a:ea typeface="Calibri" pitchFamily="34" charset="-122"/>
+                <a:cs typeface="Calibri" pitchFamily="34" charset="-120"/>
+              </a:rPr>
+              <a:t>🧠 SHAP waterfall</a:t>
+            </a:r>
+            <a:endParaRPr lang="en-US" sz="1250" dirty="0"/>
+          </a:p>
+        </p:txBody>
+      </p:sp>
+      <p:sp>
+        <p:nvSpPr>
+          <p:cNvPr id="12" name="Text 10"/>
+          <p:cNvSpPr/>
+          <p:nvPr/>
+        </p:nvSpPr>
+        <p:spPr>
+          <a:xfrm>
+            <a:off x="603504" y="4334256"/>
+            <a:ext cx="3913632" cy="356616"/>
           </a:xfrm>
           <a:prstGeom prst="rect">
             <a:avLst/>
@@ -38591,32 +39268,12 @@
           <a:p>
             <a:pPr indent="0" marL="0">
               <a:lnSpc>
-                <a:spcPct val="105000"/>
-              </a:lnSpc>
-              <a:buNone/>
-            </a:pPr>
-            <a:r>
-              <a:rPr lang="en-US" sz="950" b="1" dirty="0">
-                <a:solidFill>
-                  <a:srgbClr val="1E2761"/>
-                </a:solidFill>
-                <a:latin typeface="Courier New" pitchFamily="34" charset="0"/>
-                <a:ea typeface="Courier New" pitchFamily="34" charset="-122"/>
-                <a:cs typeface="Courier New" pitchFamily="34" charset="-120"/>
-              </a:rPr>
-              <a:t>Le kernel qui « sauve »</a:t>
-            </a:r>
-            <a:endParaRPr lang="en-US" sz="950" dirty="0"/>
-          </a:p>
-          <a:p>
-            <a:pPr indent="0" marL="0">
-              <a:lnSpc>
-                <a:spcPct val="105000"/>
-              </a:lnSpc>
-              <a:buNone/>
-            </a:pPr>
-            <a:r>
-              <a:rPr lang="en-US" sz="900" dirty="0">
+                <a:spcPct val="106000"/>
+              </a:lnSpc>
+              <a:buNone/>
+            </a:pPr>
+            <a:r>
+              <a:rPr lang="en-US" sz="1000" dirty="0">
                 <a:solidFill>
                   <a:srgbClr val="2A3550"/>
                 </a:solidFill>
@@ -38624,26 +39281,42 @@
                 <a:ea typeface="Calibri" pitchFamily="34" charset="-122"/>
                 <a:cs typeface="Calibri" pitchFamily="34" charset="-120"/>
               </a:rPr>
-              <a:t>imports supprimés mais encore en mémoire → Restart &amp; Run All ! (S3_P4)</a:t>
-            </a:r>
-            <a:endParaRPr lang="en-US" sz="950" dirty="0"/>
-          </a:p>
-        </p:txBody>
-      </p:sp>
-      <p:sp>
-        <p:nvSpPr>
-          <p:cNvPr id="16" name="Shape 14"/>
-          <p:cNvSpPr/>
-          <p:nvPr/>
-        </p:nvSpPr>
-        <p:spPr>
-          <a:xfrm>
-            <a:off x="4681728" y="2103120"/>
-            <a:ext cx="4041648" cy="804672"/>
+              <a:t>Expliquer UN client : chaque variable pousse la décision vers « défaut » ou « rembourse ». Obligatoire en banque !</a:t>
+            </a:r>
+            <a:endParaRPr lang="en-US" sz="1050" dirty="0"/>
+          </a:p>
+        </p:txBody>
+      </p:sp>
+      <p:graphicFrame>
+        <p:nvGraphicFramePr>
+          <p:cNvPr id="13" name="Chart 0" descr=""/>
+          <p:cNvGraphicFramePr/>
+          <p:nvPr/>
+        </p:nvGraphicFramePr>
+        <p:xfrm>
+          <a:off x="4846320" y="1188720"/>
+          <a:ext cx="3840480" cy="2468880"/>
+        </p:xfrm>
+        <a:graphic xmlns:a="http://schemas.openxmlformats.org/drawingml/2006/main">
+          <a:graphicData uri="http://schemas.openxmlformats.org/drawingml/2006/chart">
+            <c:chart xmlns:c="http://schemas.openxmlformats.org/drawingml/2006/chart" r:id="rId1"/>
+          </a:graphicData>
+        </a:graphic>
+      </p:graphicFrame>
+      <p:sp>
+        <p:nvSpPr>
+          <p:cNvPr id="14" name="Shape 11"/>
+          <p:cNvSpPr/>
+          <p:nvPr/>
+        </p:nvSpPr>
+        <p:spPr>
+          <a:xfrm>
+            <a:off x="4846320" y="3840480"/>
+            <a:ext cx="3840480" cy="960120"/>
           </a:xfrm>
           <a:prstGeom prst="roundRect">
             <a:avLst>
-              <a:gd name="adj" fmla="val 6818"/>
+              <a:gd name="adj" fmla="val 5714"/>
             </a:avLst>
           </a:prstGeom>
           <a:solidFill>
@@ -38661,34 +39334,14 @@
       </p:sp>
       <p:sp>
         <p:nvSpPr>
-          <p:cNvPr id="17" name="Shape 15"/>
-          <p:cNvSpPr/>
-          <p:nvPr/>
-        </p:nvSpPr>
-        <p:spPr>
-          <a:xfrm>
-            <a:off x="4791456" y="2340864"/>
-            <a:ext cx="329184" cy="329184"/>
-          </a:xfrm>
-          <a:prstGeom prst="ellipse">
-            <a:avLst/>
-          </a:prstGeom>
-          <a:solidFill>
-            <a:srgbClr val="D64550"/>
-          </a:solidFill>
-          <a:ln/>
-        </p:spPr>
-      </p:sp>
-      <p:sp>
-        <p:nvSpPr>
-          <p:cNvPr id="18" name="Text 16"/>
-          <p:cNvSpPr/>
-          <p:nvPr/>
-        </p:nvSpPr>
-        <p:spPr>
-          <a:xfrm>
-            <a:off x="4791456" y="2331720"/>
-            <a:ext cx="329184" cy="329184"/>
+          <p:cNvPr id="15" name="Text 12"/>
+          <p:cNvSpPr/>
+          <p:nvPr/>
+        </p:nvSpPr>
+        <p:spPr>
+          <a:xfrm>
+            <a:off x="4992624" y="3950208"/>
+            <a:ext cx="3547872" cy="274320"/>
           </a:xfrm>
           <a:prstGeom prst="rect">
             <a:avLst/>
@@ -38700,34 +39353,34 @@
           <a:bodyPr wrap="square" lIns="0" tIns="0" rIns="0" bIns="0" rtlCol="0" anchor="ctr"/>
           <a:lstStyle/>
           <a:p>
-            <a:pPr algn="ctr" indent="0" marL="0">
-              <a:buNone/>
-            </a:pPr>
-            <a:r>
-              <a:rPr lang="en-US" sz="1300" b="1" dirty="0">
-                <a:solidFill>
-                  <a:srgbClr val="FFFFFF"/>
-                </a:solidFill>
-                <a:latin typeface="Calibri" pitchFamily="34" charset="0"/>
-                <a:ea typeface="Calibri" pitchFamily="34" charset="-122"/>
-                <a:cs typeface="Calibri" pitchFamily="34" charset="-120"/>
-              </a:rPr>
-              <a:t>4</a:t>
-            </a:r>
-            <a:endParaRPr lang="en-US" sz="1300" dirty="0"/>
-          </a:p>
-        </p:txBody>
-      </p:sp>
-      <p:sp>
-        <p:nvSpPr>
-          <p:cNvPr id="19" name="Text 17"/>
-          <p:cNvSpPr/>
-          <p:nvPr/>
-        </p:nvSpPr>
-        <p:spPr>
-          <a:xfrm>
-            <a:off x="5230368" y="2176272"/>
-            <a:ext cx="3401568" cy="685800"/>
+            <a:pPr indent="0" marL="0">
+              <a:buNone/>
+            </a:pPr>
+            <a:r>
+              <a:rPr lang="en-US" sz="1250" b="1" dirty="0">
+                <a:solidFill>
+                  <a:srgbClr val="1E2761"/>
+                </a:solidFill>
+                <a:latin typeface="Calibri" pitchFamily="34" charset="0"/>
+                <a:ea typeface="Calibri" pitchFamily="34" charset="-122"/>
+                <a:cs typeface="Calibri" pitchFamily="34" charset="-120"/>
+              </a:rPr>
+              <a:t>🔍 Lire la ROC &amp; l'AUC</a:t>
+            </a:r>
+            <a:endParaRPr lang="en-US" sz="1250" dirty="0"/>
+          </a:p>
+        </p:txBody>
+      </p:sp>
+      <p:sp>
+        <p:nvSpPr>
+          <p:cNvPr id="16" name="Text 13"/>
+          <p:cNvSpPr/>
+          <p:nvPr/>
+        </p:nvSpPr>
+        <p:spPr>
+          <a:xfrm>
+            <a:off x="4992624" y="4242816"/>
+            <a:ext cx="3547872" cy="448056"/>
           </a:xfrm>
           <a:prstGeom prst="rect">
             <a:avLst/>
@@ -38741,32 +39394,12 @@
           <a:p>
             <a:pPr indent="0" marL="0">
               <a:lnSpc>
-                <a:spcPct val="105000"/>
-              </a:lnSpc>
-              <a:buNone/>
-            </a:pPr>
-            <a:r>
-              <a:rPr lang="en-US" sz="950" b="1" dirty="0">
-                <a:solidFill>
-                  <a:srgbClr val="1E2761"/>
-                </a:solidFill>
-                <a:latin typeface="Courier New" pitchFamily="34" charset="0"/>
-                <a:ea typeface="Courier New" pitchFamily="34" charset="-122"/>
-                <a:cs typeface="Courier New" pitchFamily="34" charset="-120"/>
-              </a:rPr>
-              <a:t>price / 1e6 exécuté 2 fois</a:t>
-            </a:r>
-            <a:endParaRPr lang="en-US" sz="950" dirty="0"/>
-          </a:p>
-          <a:p>
-            <a:pPr indent="0" marL="0">
-              <a:lnSpc>
-                <a:spcPct val="105000"/>
-              </a:lnSpc>
-              <a:buNone/>
-            </a:pPr>
-            <a:r>
-              <a:rPr lang="en-US" sz="900" dirty="0">
+                <a:spcPct val="106000"/>
+              </a:lnSpc>
+              <a:buNone/>
+            </a:pPr>
+            <a:r>
+              <a:rPr lang="en-US" sz="1000" dirty="0">
                 <a:solidFill>
                   <a:srgbClr val="2A3550"/>
                 </a:solidFill>
@@ -38774,609 +39407,9 @@
                 <a:ea typeface="Calibri" pitchFamily="34" charset="-122"/>
                 <a:cs typeface="Calibri" pitchFamily="34" charset="-120"/>
               </a:rPr>
-              <a:t>cellule non-idempotente → tous les résultats faussés (S1_P2)</a:t>
-            </a:r>
-            <a:endParaRPr lang="en-US" sz="950" dirty="0"/>
-          </a:p>
-        </p:txBody>
-      </p:sp>
-      <p:sp>
-        <p:nvSpPr>
-          <p:cNvPr id="20" name="Shape 18"/>
-          <p:cNvSpPr/>
-          <p:nvPr/>
-        </p:nvSpPr>
-        <p:spPr>
-          <a:xfrm>
-            <a:off x="457200" y="3017520"/>
-            <a:ext cx="4041648" cy="804672"/>
-          </a:xfrm>
-          <a:prstGeom prst="roundRect">
-            <a:avLst>
-              <a:gd name="adj" fmla="val 6818"/>
-            </a:avLst>
-          </a:prstGeom>
-          <a:solidFill>
-            <a:srgbClr val="EEF4FE"/>
-          </a:solidFill>
-          <a:ln/>
-          <a:effectLst>
-            <a:outerShdw sx="100000" sy="100000" kx="0" ky="0" algn="bl" rotWithShape="0" blurRad="88900" dist="25400" dir="2700000">
-              <a:srgbClr val="000000">
-                <a:alpha val="14000"/>
-              </a:srgbClr>
-            </a:outerShdw>
-          </a:effectLst>
-        </p:spPr>
-      </p:sp>
-      <p:sp>
-        <p:nvSpPr>
-          <p:cNvPr id="21" name="Shape 19"/>
-          <p:cNvSpPr/>
-          <p:nvPr/>
-        </p:nvSpPr>
-        <p:spPr>
-          <a:xfrm>
-            <a:off x="566928" y="3255264"/>
-            <a:ext cx="329184" cy="329184"/>
-          </a:xfrm>
-          <a:prstGeom prst="ellipse">
-            <a:avLst/>
-          </a:prstGeom>
-          <a:solidFill>
-            <a:srgbClr val="D64550"/>
-          </a:solidFill>
-          <a:ln/>
-        </p:spPr>
-      </p:sp>
-      <p:sp>
-        <p:nvSpPr>
-          <p:cNvPr id="22" name="Text 20"/>
-          <p:cNvSpPr/>
-          <p:nvPr/>
-        </p:nvSpPr>
-        <p:spPr>
-          <a:xfrm>
-            <a:off x="566928" y="3246120"/>
-            <a:ext cx="329184" cy="329184"/>
-          </a:xfrm>
-          <a:prstGeom prst="rect">
-            <a:avLst/>
-          </a:prstGeom>
-          <a:noFill/>
-          <a:ln/>
-        </p:spPr>
-        <p:txBody>
-          <a:bodyPr wrap="square" lIns="0" tIns="0" rIns="0" bIns="0" rtlCol="0" anchor="ctr"/>
-          <a:lstStyle/>
-          <a:p>
-            <a:pPr algn="ctr" indent="0" marL="0">
-              <a:buNone/>
-            </a:pPr>
-            <a:r>
-              <a:rPr lang="en-US" sz="1300" b="1" dirty="0">
-                <a:solidFill>
-                  <a:srgbClr val="FFFFFF"/>
-                </a:solidFill>
-                <a:latin typeface="Calibri" pitchFamily="34" charset="0"/>
-                <a:ea typeface="Calibri" pitchFamily="34" charset="-122"/>
-                <a:cs typeface="Calibri" pitchFamily="34" charset="-120"/>
-              </a:rPr>
-              <a:t>5</a:t>
-            </a:r>
-            <a:endParaRPr lang="en-US" sz="1300" dirty="0"/>
-          </a:p>
-        </p:txBody>
-      </p:sp>
-      <p:sp>
-        <p:nvSpPr>
-          <p:cNvPr id="23" name="Text 21"/>
-          <p:cNvSpPr/>
-          <p:nvPr/>
-        </p:nvSpPr>
-        <p:spPr>
-          <a:xfrm>
-            <a:off x="1005840" y="3090672"/>
-            <a:ext cx="3401568" cy="685800"/>
-          </a:xfrm>
-          <a:prstGeom prst="rect">
-            <a:avLst/>
-          </a:prstGeom>
-          <a:noFill/>
-          <a:ln/>
-        </p:spPr>
-        <p:txBody>
-          <a:bodyPr wrap="square" lIns="0" tIns="0" rIns="0" bIns="0" rtlCol="0" anchor="t"/>
-          <a:lstStyle/>
-          <a:p>
-            <a:pPr indent="0" marL="0">
-              <a:lnSpc>
-                <a:spcPct val="105000"/>
-              </a:lnSpc>
-              <a:buNone/>
-            </a:pPr>
-            <a:r>
-              <a:rPr lang="en-US" sz="950" b="1" dirty="0">
-                <a:solidFill>
-                  <a:srgbClr val="1E2761"/>
-                </a:solidFill>
-                <a:latin typeface="Courier New" pitchFamily="34" charset="0"/>
-                <a:ea typeface="Courier New" pitchFamily="34" charset="-122"/>
-                <a:cs typeface="Courier New" pitchFamily="34" charset="-120"/>
-              </a:rPr>
-              <a:t>b = a  sur une liste</a:t>
-            </a:r>
-            <a:endParaRPr lang="en-US" sz="950" dirty="0"/>
-          </a:p>
-          <a:p>
-            <a:pPr indent="0" marL="0">
-              <a:lnSpc>
-                <a:spcPct val="105000"/>
-              </a:lnSpc>
-              <a:buNone/>
-            </a:pPr>
-            <a:r>
-              <a:rPr lang="en-US" sz="900" dirty="0">
-                <a:solidFill>
-                  <a:srgbClr val="2A3550"/>
-                </a:solidFill>
-                <a:latin typeface="Calibri" pitchFamily="34" charset="0"/>
-                <a:ea typeface="Calibri" pitchFamily="34" charset="-122"/>
-                <a:cs typeface="Calibri" pitchFamily="34" charset="-120"/>
-              </a:rPr>
-              <a:t>pas une copie ! .copy() sinon modifications partagées (day2)</a:t>
-            </a:r>
-            <a:endParaRPr lang="en-US" sz="950" dirty="0"/>
-          </a:p>
-        </p:txBody>
-      </p:sp>
-      <p:sp>
-        <p:nvSpPr>
-          <p:cNvPr id="24" name="Shape 22"/>
-          <p:cNvSpPr/>
-          <p:nvPr/>
-        </p:nvSpPr>
-        <p:spPr>
-          <a:xfrm>
-            <a:off x="4681728" y="3017520"/>
-            <a:ext cx="4041648" cy="804672"/>
-          </a:xfrm>
-          <a:prstGeom prst="roundRect">
-            <a:avLst>
-              <a:gd name="adj" fmla="val 6818"/>
-            </a:avLst>
-          </a:prstGeom>
-          <a:solidFill>
-            <a:srgbClr val="EEF4FE"/>
-          </a:solidFill>
-          <a:ln/>
-          <a:effectLst>
-            <a:outerShdw sx="100000" sy="100000" kx="0" ky="0" algn="bl" rotWithShape="0" blurRad="88900" dist="25400" dir="2700000">
-              <a:srgbClr val="000000">
-                <a:alpha val="14000"/>
-              </a:srgbClr>
-            </a:outerShdw>
-          </a:effectLst>
-        </p:spPr>
-      </p:sp>
-      <p:sp>
-        <p:nvSpPr>
-          <p:cNvPr id="25" name="Shape 23"/>
-          <p:cNvSpPr/>
-          <p:nvPr/>
-        </p:nvSpPr>
-        <p:spPr>
-          <a:xfrm>
-            <a:off x="4791456" y="3255264"/>
-            <a:ext cx="329184" cy="329184"/>
-          </a:xfrm>
-          <a:prstGeom prst="ellipse">
-            <a:avLst/>
-          </a:prstGeom>
-          <a:solidFill>
-            <a:srgbClr val="D64550"/>
-          </a:solidFill>
-          <a:ln/>
-        </p:spPr>
-      </p:sp>
-      <p:sp>
-        <p:nvSpPr>
-          <p:cNvPr id="26" name="Text 24"/>
-          <p:cNvSpPr/>
-          <p:nvPr/>
-        </p:nvSpPr>
-        <p:spPr>
-          <a:xfrm>
-            <a:off x="4791456" y="3246120"/>
-            <a:ext cx="329184" cy="329184"/>
-          </a:xfrm>
-          <a:prstGeom prst="rect">
-            <a:avLst/>
-          </a:prstGeom>
-          <a:noFill/>
-          <a:ln/>
-        </p:spPr>
-        <p:txBody>
-          <a:bodyPr wrap="square" lIns="0" tIns="0" rIns="0" bIns="0" rtlCol="0" anchor="ctr"/>
-          <a:lstStyle/>
-          <a:p>
-            <a:pPr algn="ctr" indent="0" marL="0">
-              <a:buNone/>
-            </a:pPr>
-            <a:r>
-              <a:rPr lang="en-US" sz="1300" b="1" dirty="0">
-                <a:solidFill>
-                  <a:srgbClr val="FFFFFF"/>
-                </a:solidFill>
-                <a:latin typeface="Calibri" pitchFamily="34" charset="0"/>
-                <a:ea typeface="Calibri" pitchFamily="34" charset="-122"/>
-                <a:cs typeface="Calibri" pitchFamily="34" charset="-120"/>
-              </a:rPr>
-              <a:t>6</a:t>
-            </a:r>
-            <a:endParaRPr lang="en-US" sz="1300" dirty="0"/>
-          </a:p>
-        </p:txBody>
-      </p:sp>
-      <p:sp>
-        <p:nvSpPr>
-          <p:cNvPr id="27" name="Text 25"/>
-          <p:cNvSpPr/>
-          <p:nvPr/>
-        </p:nvSpPr>
-        <p:spPr>
-          <a:xfrm>
-            <a:off x="5230368" y="3090672"/>
-            <a:ext cx="3401568" cy="685800"/>
-          </a:xfrm>
-          <a:prstGeom prst="rect">
-            <a:avLst/>
-          </a:prstGeom>
-          <a:noFill/>
-          <a:ln/>
-        </p:spPr>
-        <p:txBody>
-          <a:bodyPr wrap="square" lIns="0" tIns="0" rIns="0" bIns="0" rtlCol="0" anchor="t"/>
-          <a:lstStyle/>
-          <a:p>
-            <a:pPr indent="0" marL="0">
-              <a:lnSpc>
-                <a:spcPct val="105000"/>
-              </a:lnSpc>
-              <a:buNone/>
-            </a:pPr>
-            <a:r>
-              <a:rPr lang="en-US" sz="950" b="1" dirty="0">
-                <a:solidFill>
-                  <a:srgbClr val="1E2761"/>
-                </a:solidFill>
-                <a:latin typeface="Courier New" pitchFamily="34" charset="0"/>
-                <a:ea typeface="Courier New" pitchFamily="34" charset="-122"/>
-                <a:cs typeface="Courier New" pitchFamily="34" charset="-120"/>
-              </a:rPr>
-              <a:t>hypot(a**2 + b**2)</a:t>
-            </a:r>
-            <a:endParaRPr lang="en-US" sz="950" dirty="0"/>
-          </a:p>
-          <a:p>
-            <a:pPr indent="0" marL="0">
-              <a:lnSpc>
-                <a:spcPct val="105000"/>
-              </a:lnSpc>
-              <a:buNone/>
-            </a:pPr>
-            <a:r>
-              <a:rPr lang="en-US" sz="900" dirty="0">
-                <a:solidFill>
-                  <a:srgbClr val="2A3550"/>
-                </a:solidFill>
-                <a:latin typeface="Calibri" pitchFamily="34" charset="0"/>
-                <a:ea typeface="Calibri" pitchFamily="34" charset="-122"/>
-                <a:cs typeface="Calibri" pitchFamily="34" charset="-120"/>
-              </a:rPr>
-              <a:t>hypoténuse de 767 km — vérifier la SIGNATURE (fonction?) (day1)</a:t>
-            </a:r>
-            <a:endParaRPr lang="en-US" sz="950" dirty="0"/>
-          </a:p>
-        </p:txBody>
-      </p:sp>
-      <p:sp>
-        <p:nvSpPr>
-          <p:cNvPr id="28" name="Shape 26"/>
-          <p:cNvSpPr/>
-          <p:nvPr/>
-        </p:nvSpPr>
-        <p:spPr>
-          <a:xfrm>
-            <a:off x="457200" y="3931920"/>
-            <a:ext cx="4041648" cy="804672"/>
-          </a:xfrm>
-          <a:prstGeom prst="roundRect">
-            <a:avLst>
-              <a:gd name="adj" fmla="val 6818"/>
-            </a:avLst>
-          </a:prstGeom>
-          <a:solidFill>
-            <a:srgbClr val="EEF4FE"/>
-          </a:solidFill>
-          <a:ln/>
-          <a:effectLst>
-            <a:outerShdw sx="100000" sy="100000" kx="0" ky="0" algn="bl" rotWithShape="0" blurRad="88900" dist="25400" dir="2700000">
-              <a:srgbClr val="000000">
-                <a:alpha val="14000"/>
-              </a:srgbClr>
-            </a:outerShdw>
-          </a:effectLst>
-        </p:spPr>
-      </p:sp>
-      <p:sp>
-        <p:nvSpPr>
-          <p:cNvPr id="29" name="Shape 27"/>
-          <p:cNvSpPr/>
-          <p:nvPr/>
-        </p:nvSpPr>
-        <p:spPr>
-          <a:xfrm>
-            <a:off x="566928" y="4169664"/>
-            <a:ext cx="329184" cy="329184"/>
-          </a:xfrm>
-          <a:prstGeom prst="ellipse">
-            <a:avLst/>
-          </a:prstGeom>
-          <a:solidFill>
-            <a:srgbClr val="D64550"/>
-          </a:solidFill>
-          <a:ln/>
-        </p:spPr>
-      </p:sp>
-      <p:sp>
-        <p:nvSpPr>
-          <p:cNvPr id="30" name="Text 28"/>
-          <p:cNvSpPr/>
-          <p:nvPr/>
-        </p:nvSpPr>
-        <p:spPr>
-          <a:xfrm>
-            <a:off x="566928" y="4160520"/>
-            <a:ext cx="329184" cy="329184"/>
-          </a:xfrm>
-          <a:prstGeom prst="rect">
-            <a:avLst/>
-          </a:prstGeom>
-          <a:noFill/>
-          <a:ln/>
-        </p:spPr>
-        <p:txBody>
-          <a:bodyPr wrap="square" lIns="0" tIns="0" rIns="0" bIns="0" rtlCol="0" anchor="ctr"/>
-          <a:lstStyle/>
-          <a:p>
-            <a:pPr algn="ctr" indent="0" marL="0">
-              <a:buNone/>
-            </a:pPr>
-            <a:r>
-              <a:rPr lang="en-US" sz="1300" b="1" dirty="0">
-                <a:solidFill>
-                  <a:srgbClr val="FFFFFF"/>
-                </a:solidFill>
-                <a:latin typeface="Calibri" pitchFamily="34" charset="0"/>
-                <a:ea typeface="Calibri" pitchFamily="34" charset="-122"/>
-                <a:cs typeface="Calibri" pitchFamily="34" charset="-120"/>
-              </a:rPr>
-              <a:t>7</a:t>
-            </a:r>
-            <a:endParaRPr lang="en-US" sz="1300" dirty="0"/>
-          </a:p>
-        </p:txBody>
-      </p:sp>
-      <p:sp>
-        <p:nvSpPr>
-          <p:cNvPr id="31" name="Text 29"/>
-          <p:cNvSpPr/>
-          <p:nvPr/>
-        </p:nvSpPr>
-        <p:spPr>
-          <a:xfrm>
-            <a:off x="1005840" y="4005072"/>
-            <a:ext cx="3401568" cy="685800"/>
-          </a:xfrm>
-          <a:prstGeom prst="rect">
-            <a:avLst/>
-          </a:prstGeom>
-          <a:noFill/>
-          <a:ln/>
-        </p:spPr>
-        <p:txBody>
-          <a:bodyPr wrap="square" lIns="0" tIns="0" rIns="0" bIns="0" rtlCol="0" anchor="t"/>
-          <a:lstStyle/>
-          <a:p>
-            <a:pPr indent="0" marL="0">
-              <a:lnSpc>
-                <a:spcPct val="105000"/>
-              </a:lnSpc>
-              <a:buNone/>
-            </a:pPr>
-            <a:r>
-              <a:rPr lang="en-US" sz="950" b="1" dirty="0">
-                <a:solidFill>
-                  <a:srgbClr val="1E2761"/>
-                </a:solidFill>
-                <a:latin typeface="Courier New" pitchFamily="34" charset="0"/>
-                <a:ea typeface="Courier New" pitchFamily="34" charset="-122"/>
-                <a:cs typeface="Courier New" pitchFamily="34" charset="-120"/>
-              </a:rPr>
-              <a:t>Accuracy 84 % sur du 85/15</a:t>
-            </a:r>
-            <a:endParaRPr lang="en-US" sz="950" dirty="0"/>
-          </a:p>
-          <a:p>
-            <a:pPr indent="0" marL="0">
-              <a:lnSpc>
-                <a:spcPct val="105000"/>
-              </a:lnSpc>
-              <a:buNone/>
-            </a:pPr>
-            <a:r>
-              <a:rPr lang="en-US" sz="900" dirty="0">
-                <a:solidFill>
-                  <a:srgbClr val="2A3550"/>
-                </a:solidFill>
-                <a:latin typeface="Calibri" pitchFamily="34" charset="0"/>
-                <a:ea typeface="Calibri" pitchFamily="34" charset="-122"/>
-                <a:cs typeface="Calibri" pitchFamily="34" charset="-120"/>
-              </a:rPr>
-              <a:t>pire que l'idiot « toujours Deny » — baseline d'abord ! (S3_P1)</a:t>
-            </a:r>
-            <a:endParaRPr lang="en-US" sz="950" dirty="0"/>
-          </a:p>
-        </p:txBody>
-      </p:sp>
-      <p:sp>
-        <p:nvSpPr>
-          <p:cNvPr id="32" name="Shape 30"/>
-          <p:cNvSpPr/>
-          <p:nvPr/>
-        </p:nvSpPr>
-        <p:spPr>
-          <a:xfrm>
-            <a:off x="4681728" y="3931920"/>
-            <a:ext cx="4041648" cy="804672"/>
-          </a:xfrm>
-          <a:prstGeom prst="roundRect">
-            <a:avLst>
-              <a:gd name="adj" fmla="val 6818"/>
-            </a:avLst>
-          </a:prstGeom>
-          <a:solidFill>
-            <a:srgbClr val="EEF4FE"/>
-          </a:solidFill>
-          <a:ln/>
-          <a:effectLst>
-            <a:outerShdw sx="100000" sy="100000" kx="0" ky="0" algn="bl" rotWithShape="0" blurRad="88900" dist="25400" dir="2700000">
-              <a:srgbClr val="000000">
-                <a:alpha val="14000"/>
-              </a:srgbClr>
-            </a:outerShdw>
-          </a:effectLst>
-        </p:spPr>
-      </p:sp>
-      <p:sp>
-        <p:nvSpPr>
-          <p:cNvPr id="33" name="Shape 31"/>
-          <p:cNvSpPr/>
-          <p:nvPr/>
-        </p:nvSpPr>
-        <p:spPr>
-          <a:xfrm>
-            <a:off x="4791456" y="4169664"/>
-            <a:ext cx="329184" cy="329184"/>
-          </a:xfrm>
-          <a:prstGeom prst="ellipse">
-            <a:avLst/>
-          </a:prstGeom>
-          <a:solidFill>
-            <a:srgbClr val="D64550"/>
-          </a:solidFill>
-          <a:ln/>
-        </p:spPr>
-      </p:sp>
-      <p:sp>
-        <p:nvSpPr>
-          <p:cNvPr id="34" name="Text 32"/>
-          <p:cNvSpPr/>
-          <p:nvPr/>
-        </p:nvSpPr>
-        <p:spPr>
-          <a:xfrm>
-            <a:off x="4791456" y="4160520"/>
-            <a:ext cx="329184" cy="329184"/>
-          </a:xfrm>
-          <a:prstGeom prst="rect">
-            <a:avLst/>
-          </a:prstGeom>
-          <a:noFill/>
-          <a:ln/>
-        </p:spPr>
-        <p:txBody>
-          <a:bodyPr wrap="square" lIns="0" tIns="0" rIns="0" bIns="0" rtlCol="0" anchor="ctr"/>
-          <a:lstStyle/>
-          <a:p>
-            <a:pPr algn="ctr" indent="0" marL="0">
-              <a:buNone/>
-            </a:pPr>
-            <a:r>
-              <a:rPr lang="en-US" sz="1300" b="1" dirty="0">
-                <a:solidFill>
-                  <a:srgbClr val="FFFFFF"/>
-                </a:solidFill>
-                <a:latin typeface="Calibri" pitchFamily="34" charset="0"/>
-                <a:ea typeface="Calibri" pitchFamily="34" charset="-122"/>
-                <a:cs typeface="Calibri" pitchFamily="34" charset="-120"/>
-              </a:rPr>
-              <a:t>8</a:t>
-            </a:r>
-            <a:endParaRPr lang="en-US" sz="1300" dirty="0"/>
-          </a:p>
-        </p:txBody>
-      </p:sp>
-      <p:sp>
-        <p:nvSpPr>
-          <p:cNvPr id="35" name="Text 33"/>
-          <p:cNvSpPr/>
-          <p:nvPr/>
-        </p:nvSpPr>
-        <p:spPr>
-          <a:xfrm>
-            <a:off x="5230368" y="4005072"/>
-            <a:ext cx="3401568" cy="685800"/>
-          </a:xfrm>
-          <a:prstGeom prst="rect">
-            <a:avLst/>
-          </a:prstGeom>
-          <a:noFill/>
-          <a:ln/>
-        </p:spPr>
-        <p:txBody>
-          <a:bodyPr wrap="square" lIns="0" tIns="0" rIns="0" bIns="0" rtlCol="0" anchor="t"/>
-          <a:lstStyle/>
-          <a:p>
-            <a:pPr indent="0" marL="0">
-              <a:lnSpc>
-                <a:spcPct val="105000"/>
-              </a:lnSpc>
-              <a:buNone/>
-            </a:pPr>
-            <a:r>
-              <a:rPr lang="en-US" sz="950" b="1" dirty="0">
-                <a:solidFill>
-                  <a:srgbClr val="1E2761"/>
-                </a:solidFill>
-                <a:latin typeface="Courier New" pitchFamily="34" charset="0"/>
-                <a:ea typeface="Courier New" pitchFamily="34" charset="-122"/>
-                <a:cs typeface="Courier New" pitchFamily="34" charset="-120"/>
-              </a:rPr>
-              <a:t>idxmin() → indice, pas valeur</a:t>
-            </a:r>
-            <a:endParaRPr lang="en-US" sz="950" dirty="0"/>
-          </a:p>
-          <a:p>
-            <a:pPr indent="0" marL="0">
-              <a:lnSpc>
-                <a:spcPct val="105000"/>
-              </a:lnSpc>
-              <a:buNone/>
-            </a:pPr>
-            <a:r>
-              <a:rPr lang="en-US" sz="900" dirty="0">
-                <a:solidFill>
-                  <a:srgbClr val="2A3550"/>
-                </a:solidFill>
-                <a:latin typeface="Calibri" pitchFamily="34" charset="0"/>
-                <a:ea typeface="Calibri" pitchFamily="34" charset="-122"/>
-                <a:cs typeface="Calibri" pitchFamily="34" charset="-120"/>
-              </a:rPr>
-              <a:t>ligne 2 = k 3 : le meilleur k n'était pas 2 ! (S4_P1)</a:t>
-            </a:r>
-            <a:endParaRPr lang="en-US" sz="950" dirty="0"/>
+              <a:t>Chaque point = un seuil différent. Grimper vite vers le coin haut-gauche = bon modèle. AUC = l'aire sous la courbe : 0.5 = hasard, 1 = parfait — LA métrique du déséquilibré.</a:t>
+            </a:r>
+            <a:endParaRPr lang="en-US" sz="1050" dirty="0"/>
           </a:p>
         </p:txBody>
       </p:sp>
@@ -39391,6 +39424,2126 @@
 <file path=ppt/slides/slide41.xml><?xml version="1.0" encoding="utf-8"?>
 <p:sld xmlns:a="http://schemas.openxmlformats.org/drawingml/2006/main" xmlns:r="http://schemas.openxmlformats.org/officeDocument/2006/relationships" xmlns:p="http://schemas.openxmlformats.org/presentationml/2006/main">
   <p:cSld name="Slide 41">
+    <p:bg>
+      <p:bgPr>
+        <a:solidFill>
+          <a:srgbClr val="FFFFFF"/>
+        </a:solidFill>
+      </p:bgPr>
+    </p:bg>
+    <p:spTree>
+      <p:nvGrpSpPr>
+        <p:cNvPr id="1" name=""/>
+        <p:cNvGrpSpPr/>
+        <p:nvPr/>
+      </p:nvGrpSpPr>
+      <p:grpSpPr>
+        <a:xfrm>
+          <a:off x="0" y="0"/>
+          <a:ext cx="0" cy="0"/>
+          <a:chOff x="0" y="0"/>
+          <a:chExt cx="0" cy="0"/>
+        </a:xfrm>
+      </p:grpSpPr>
+      <p:sp>
+        <p:nvSpPr>
+          <p:cNvPr id="2" name="Text 0"/>
+          <p:cNvSpPr/>
+          <p:nvPr/>
+        </p:nvSpPr>
+        <p:spPr>
+          <a:xfrm>
+            <a:off x="457200" y="201168"/>
+            <a:ext cx="8229600" cy="256032"/>
+          </a:xfrm>
+          <a:prstGeom prst="rect">
+            <a:avLst/>
+          </a:prstGeom>
+          <a:noFill/>
+          <a:ln/>
+        </p:spPr>
+        <p:txBody>
+          <a:bodyPr wrap="square" lIns="0" tIns="0" rIns="0" bIns="0" rtlCol="0" anchor="ctr"/>
+          <a:lstStyle/>
+          <a:p>
+            <a:pPr indent="0" marL="0">
+              <a:buNone/>
+            </a:pPr>
+            <a:r>
+              <a:rPr lang="en-US" sz="1100" b="1" spc="200" kern="0" dirty="0">
+                <a:solidFill>
+                  <a:srgbClr val="017A61"/>
+                </a:solidFill>
+                <a:latin typeface="Calibri" pitchFamily="34" charset="0"/>
+                <a:ea typeface="Calibri" pitchFamily="34" charset="-122"/>
+                <a:cs typeface="Calibri" pitchFamily="34" charset="-120"/>
+              </a:rPr>
+              <a:t>S8 · L'APPRENTISSAGE NON SUPERVISÉ</a:t>
+            </a:r>
+            <a:endParaRPr lang="en-US" sz="1100" dirty="0"/>
+          </a:p>
+        </p:txBody>
+      </p:sp>
+      <p:sp>
+        <p:nvSpPr>
+          <p:cNvPr id="3" name="Text 1"/>
+          <p:cNvSpPr/>
+          <p:nvPr/>
+        </p:nvSpPr>
+        <p:spPr>
+          <a:xfrm>
+            <a:off x="457200" y="438912"/>
+            <a:ext cx="8229600" cy="566928"/>
+          </a:xfrm>
+          <a:prstGeom prst="rect">
+            <a:avLst/>
+          </a:prstGeom>
+          <a:noFill/>
+          <a:ln/>
+        </p:spPr>
+        <p:txBody>
+          <a:bodyPr wrap="square" lIns="0" tIns="0" rIns="0" bIns="0" rtlCol="0" anchor="ctr"/>
+          <a:lstStyle/>
+          <a:p>
+            <a:pPr indent="0" marL="0">
+              <a:buNone/>
+            </a:pPr>
+            <a:r>
+              <a:rPr lang="en-US" sz="2700" b="1" dirty="0">
+                <a:solidFill>
+                  <a:srgbClr val="1E2761"/>
+                </a:solidFill>
+                <a:latin typeface="Calibri" pitchFamily="34" charset="0"/>
+                <a:ea typeface="Calibri" pitchFamily="34" charset="-122"/>
+                <a:cs typeface="Calibri" pitchFamily="34" charset="-120"/>
+              </a:rPr>
+              <a:t>S8 : le clustering — découvrir des groupes sans étiquettes</a:t>
+            </a:r>
+            <a:endParaRPr lang="en-US" sz="2700" dirty="0"/>
+          </a:p>
+        </p:txBody>
+      </p:sp>
+      <p:sp>
+        <p:nvSpPr>
+          <p:cNvPr id="4" name="Shape 2"/>
+          <p:cNvSpPr/>
+          <p:nvPr/>
+        </p:nvSpPr>
+        <p:spPr>
+          <a:xfrm>
+            <a:off x="457200" y="1188720"/>
+            <a:ext cx="4206240" cy="1188720"/>
+          </a:xfrm>
+          <a:prstGeom prst="roundRect">
+            <a:avLst>
+              <a:gd name="adj" fmla="val 4615"/>
+            </a:avLst>
+          </a:prstGeom>
+          <a:solidFill>
+            <a:srgbClr val="E9FAF5"/>
+          </a:solidFill>
+          <a:ln/>
+          <a:effectLst>
+            <a:outerShdw sx="100000" sy="100000" kx="0" ky="0" algn="bl" rotWithShape="0" blurRad="88900" dist="25400" dir="2700000">
+              <a:srgbClr val="000000">
+                <a:alpha val="14000"/>
+              </a:srgbClr>
+            </a:outerShdw>
+          </a:effectLst>
+        </p:spPr>
+      </p:sp>
+      <p:sp>
+        <p:nvSpPr>
+          <p:cNvPr id="5" name="Text 3"/>
+          <p:cNvSpPr/>
+          <p:nvPr/>
+        </p:nvSpPr>
+        <p:spPr>
+          <a:xfrm>
+            <a:off x="603504" y="1298448"/>
+            <a:ext cx="3913632" cy="274320"/>
+          </a:xfrm>
+          <a:prstGeom prst="rect">
+            <a:avLst/>
+          </a:prstGeom>
+          <a:noFill/>
+          <a:ln/>
+        </p:spPr>
+        <p:txBody>
+          <a:bodyPr wrap="square" lIns="0" tIns="0" rIns="0" bIns="0" rtlCol="0" anchor="ctr"/>
+          <a:lstStyle/>
+          <a:p>
+            <a:pPr indent="0" marL="0">
+              <a:buNone/>
+            </a:pPr>
+            <a:r>
+              <a:rPr lang="en-US" sz="1250" b="1" dirty="0">
+                <a:solidFill>
+                  <a:srgbClr val="1E2761"/>
+                </a:solidFill>
+                <a:latin typeface="Calibri" pitchFamily="34" charset="0"/>
+                <a:ea typeface="Calibri" pitchFamily="34" charset="-122"/>
+                <a:cs typeface="Calibri" pitchFamily="34" charset="-120"/>
+              </a:rPr>
+              <a:t>Changement de monde : plus de y !</a:t>
+            </a:r>
+            <a:endParaRPr lang="en-US" sz="1250" dirty="0"/>
+          </a:p>
+        </p:txBody>
+      </p:sp>
+      <p:sp>
+        <p:nvSpPr>
+          <p:cNvPr id="6" name="Text 4"/>
+          <p:cNvSpPr/>
+          <p:nvPr/>
+        </p:nvSpPr>
+        <p:spPr>
+          <a:xfrm>
+            <a:off x="603504" y="1591056"/>
+            <a:ext cx="3913632" cy="676656"/>
+          </a:xfrm>
+          <a:prstGeom prst="rect">
+            <a:avLst/>
+          </a:prstGeom>
+          <a:noFill/>
+          <a:ln/>
+        </p:spPr>
+        <p:txBody>
+          <a:bodyPr wrap="square" lIns="0" tIns="0" rIns="0" bIns="0" rtlCol="0" anchor="t"/>
+          <a:lstStyle/>
+          <a:p>
+            <a:pPr indent="0" marL="0">
+              <a:lnSpc>
+                <a:spcPct val="106000"/>
+              </a:lnSpc>
+              <a:buNone/>
+            </a:pPr>
+            <a:r>
+              <a:rPr lang="en-US" sz="1050" dirty="0">
+                <a:solidFill>
+                  <a:srgbClr val="2A3550"/>
+                </a:solidFill>
+                <a:latin typeface="Calibri" pitchFamily="34" charset="0"/>
+                <a:ea typeface="Calibri" pitchFamily="34" charset="-122"/>
+                <a:cs typeface="Calibri" pitchFamily="34" charset="-120"/>
+              </a:rPr>
+              <a:t>On donne des données SANS réponses, et l'algorithme découvre tout seul des groupes (clusters) de points similaires. Segmentation clients, anomalies…</a:t>
+            </a:r>
+            <a:endParaRPr lang="en-US" sz="1050" dirty="0"/>
+          </a:p>
+        </p:txBody>
+      </p:sp>
+      <p:sp>
+        <p:nvSpPr>
+          <p:cNvPr id="7" name="Shape 5"/>
+          <p:cNvSpPr/>
+          <p:nvPr/>
+        </p:nvSpPr>
+        <p:spPr>
+          <a:xfrm>
+            <a:off x="457200" y="2560320"/>
+            <a:ext cx="4206240" cy="1051560"/>
+          </a:xfrm>
+          <a:prstGeom prst="roundRect">
+            <a:avLst>
+              <a:gd name="adj" fmla="val 5217"/>
+            </a:avLst>
+          </a:prstGeom>
+          <a:solidFill>
+            <a:srgbClr val="EEF4FE"/>
+          </a:solidFill>
+          <a:ln/>
+          <a:effectLst>
+            <a:outerShdw sx="100000" sy="100000" kx="0" ky="0" algn="bl" rotWithShape="0" blurRad="88900" dist="25400" dir="2700000">
+              <a:srgbClr val="000000">
+                <a:alpha val="14000"/>
+              </a:srgbClr>
+            </a:outerShdw>
+          </a:effectLst>
+        </p:spPr>
+      </p:sp>
+      <p:sp>
+        <p:nvSpPr>
+          <p:cNvPr id="8" name="Text 6"/>
+          <p:cNvSpPr/>
+          <p:nvPr/>
+        </p:nvSpPr>
+        <p:spPr>
+          <a:xfrm>
+            <a:off x="603504" y="2670048"/>
+            <a:ext cx="3913632" cy="274320"/>
+          </a:xfrm>
+          <a:prstGeom prst="rect">
+            <a:avLst/>
+          </a:prstGeom>
+          <a:noFill/>
+          <a:ln/>
+        </p:spPr>
+        <p:txBody>
+          <a:bodyPr wrap="square" lIns="0" tIns="0" rIns="0" bIns="0" rtlCol="0" anchor="ctr"/>
+          <a:lstStyle/>
+          <a:p>
+            <a:pPr indent="0" marL="0">
+              <a:buNone/>
+            </a:pPr>
+            <a:r>
+              <a:rPr lang="en-US" sz="1250" b="1" dirty="0">
+                <a:solidFill>
+                  <a:srgbClr val="1E2761"/>
+                </a:solidFill>
+                <a:latin typeface="Calibri" pitchFamily="34" charset="0"/>
+                <a:ea typeface="Calibri" pitchFamily="34" charset="-122"/>
+                <a:cs typeface="Calibri" pitchFamily="34" charset="-120"/>
+              </a:rPr>
+              <a:t>KMeans : par CENTRES</a:t>
+            </a:r>
+            <a:endParaRPr lang="en-US" sz="1250" dirty="0"/>
+          </a:p>
+        </p:txBody>
+      </p:sp>
+      <p:sp>
+        <p:nvSpPr>
+          <p:cNvPr id="9" name="Text 7"/>
+          <p:cNvSpPr/>
+          <p:nvPr/>
+        </p:nvSpPr>
+        <p:spPr>
+          <a:xfrm>
+            <a:off x="603504" y="2962656"/>
+            <a:ext cx="3913632" cy="539496"/>
+          </a:xfrm>
+          <a:prstGeom prst="rect">
+            <a:avLst/>
+          </a:prstGeom>
+          <a:noFill/>
+          <a:ln/>
+        </p:spPr>
+        <p:txBody>
+          <a:bodyPr wrap="square" lIns="0" tIns="0" rIns="0" bIns="0" rtlCol="0" anchor="t"/>
+          <a:lstStyle/>
+          <a:p>
+            <a:pPr indent="0" marL="0">
+              <a:lnSpc>
+                <a:spcPct val="106000"/>
+              </a:lnSpc>
+              <a:buNone/>
+            </a:pPr>
+            <a:r>
+              <a:rPr lang="en-US" sz="1000" dirty="0">
+                <a:solidFill>
+                  <a:srgbClr val="2A3550"/>
+                </a:solidFill>
+                <a:latin typeface="Calibri" pitchFamily="34" charset="0"/>
+                <a:ea typeface="Calibri" pitchFamily="34" charset="-122"/>
+                <a:cs typeface="Calibri" pitchFamily="34" charset="-120"/>
+              </a:rPr>
+              <a:t>k centres → chaque point rejoint le plus proche → les centres bougent → répète. Il faut choisir k, et il ne fait que des clusters RONDS.</a:t>
+            </a:r>
+            <a:endParaRPr lang="en-US" sz="1050" dirty="0"/>
+          </a:p>
+        </p:txBody>
+      </p:sp>
+      <p:sp>
+        <p:nvSpPr>
+          <p:cNvPr id="10" name="Shape 8"/>
+          <p:cNvSpPr/>
+          <p:nvPr/>
+        </p:nvSpPr>
+        <p:spPr>
+          <a:xfrm>
+            <a:off x="457200" y="3749040"/>
+            <a:ext cx="4206240" cy="1051560"/>
+          </a:xfrm>
+          <a:prstGeom prst="roundRect">
+            <a:avLst>
+              <a:gd name="adj" fmla="val 5217"/>
+            </a:avLst>
+          </a:prstGeom>
+          <a:solidFill>
+            <a:srgbClr val="EEF4FE"/>
+          </a:solidFill>
+          <a:ln/>
+          <a:effectLst>
+            <a:outerShdw sx="100000" sy="100000" kx="0" ky="0" algn="bl" rotWithShape="0" blurRad="88900" dist="25400" dir="2700000">
+              <a:srgbClr val="000000">
+                <a:alpha val="14000"/>
+              </a:srgbClr>
+            </a:outerShdw>
+          </a:effectLst>
+        </p:spPr>
+      </p:sp>
+      <p:sp>
+        <p:nvSpPr>
+          <p:cNvPr id="11" name="Text 9"/>
+          <p:cNvSpPr/>
+          <p:nvPr/>
+        </p:nvSpPr>
+        <p:spPr>
+          <a:xfrm>
+            <a:off x="603504" y="3858768"/>
+            <a:ext cx="3913632" cy="274320"/>
+          </a:xfrm>
+          <a:prstGeom prst="rect">
+            <a:avLst/>
+          </a:prstGeom>
+          <a:noFill/>
+          <a:ln/>
+        </p:spPr>
+        <p:txBody>
+          <a:bodyPr wrap="square" lIns="0" tIns="0" rIns="0" bIns="0" rtlCol="0" anchor="ctr"/>
+          <a:lstStyle/>
+          <a:p>
+            <a:pPr indent="0" marL="0">
+              <a:buNone/>
+            </a:pPr>
+            <a:r>
+              <a:rPr lang="en-US" sz="1250" b="1" dirty="0">
+                <a:solidFill>
+                  <a:srgbClr val="1E2761"/>
+                </a:solidFill>
+                <a:latin typeface="Calibri" pitchFamily="34" charset="0"/>
+                <a:ea typeface="Calibri" pitchFamily="34" charset="-122"/>
+                <a:cs typeface="Calibri" pitchFamily="34" charset="-120"/>
+              </a:rPr>
+              <a:t>DBSCAN : par DENSITÉ</a:t>
+            </a:r>
+            <a:endParaRPr lang="en-US" sz="1250" dirty="0"/>
+          </a:p>
+        </p:txBody>
+      </p:sp>
+      <p:sp>
+        <p:nvSpPr>
+          <p:cNvPr id="12" name="Text 10"/>
+          <p:cNvSpPr/>
+          <p:nvPr/>
+        </p:nvSpPr>
+        <p:spPr>
+          <a:xfrm>
+            <a:off x="603504" y="4151376"/>
+            <a:ext cx="3913632" cy="539496"/>
+          </a:xfrm>
+          <a:prstGeom prst="rect">
+            <a:avLst/>
+          </a:prstGeom>
+          <a:noFill/>
+          <a:ln/>
+        </p:spPr>
+        <p:txBody>
+          <a:bodyPr wrap="square" lIns="0" tIns="0" rIns="0" bIns="0" rtlCol="0" anchor="t"/>
+          <a:lstStyle/>
+          <a:p>
+            <a:pPr indent="0" marL="0">
+              <a:lnSpc>
+                <a:spcPct val="106000"/>
+              </a:lnSpc>
+              <a:buNone/>
+            </a:pPr>
+            <a:r>
+              <a:rPr lang="en-US" sz="1000" dirty="0">
+                <a:solidFill>
+                  <a:srgbClr val="2A3550"/>
+                </a:solidFill>
+                <a:latin typeface="Calibri" pitchFamily="34" charset="0"/>
+                <a:ea typeface="Calibri" pitchFamily="34" charset="-122"/>
+                <a:cs typeface="Calibri" pitchFamily="34" charset="-120"/>
+              </a:rPr>
+              <a:t>Pas de k à choisir ! Regroupe les points denses (eps, min_samples), marque les isolés comme BRUIT (−1), gère les formes quelconques.</a:t>
+            </a:r>
+            <a:endParaRPr lang="en-US" sz="1050" dirty="0"/>
+          </a:p>
+        </p:txBody>
+      </p:sp>
+      <p:sp>
+        <p:nvSpPr>
+          <p:cNvPr id="13" name="Shape 11"/>
+          <p:cNvSpPr/>
+          <p:nvPr/>
+        </p:nvSpPr>
+        <p:spPr>
+          <a:xfrm>
+            <a:off x="4846320" y="1188720"/>
+            <a:ext cx="3840480" cy="1463040"/>
+          </a:xfrm>
+          <a:prstGeom prst="roundRect">
+            <a:avLst>
+              <a:gd name="adj" fmla="val 3750"/>
+            </a:avLst>
+          </a:prstGeom>
+          <a:solidFill>
+            <a:srgbClr val="EEF4FE"/>
+          </a:solidFill>
+          <a:ln/>
+          <a:effectLst>
+            <a:outerShdw sx="100000" sy="100000" kx="0" ky="0" algn="bl" rotWithShape="0" blurRad="88900" dist="25400" dir="2700000">
+              <a:srgbClr val="000000">
+                <a:alpha val="14000"/>
+              </a:srgbClr>
+            </a:outerShdw>
+          </a:effectLst>
+        </p:spPr>
+      </p:sp>
+      <p:sp>
+        <p:nvSpPr>
+          <p:cNvPr id="14" name="Text 12"/>
+          <p:cNvSpPr/>
+          <p:nvPr/>
+        </p:nvSpPr>
+        <p:spPr>
+          <a:xfrm>
+            <a:off x="4992624" y="1298448"/>
+            <a:ext cx="3547872" cy="274320"/>
+          </a:xfrm>
+          <a:prstGeom prst="rect">
+            <a:avLst/>
+          </a:prstGeom>
+          <a:noFill/>
+          <a:ln/>
+        </p:spPr>
+        <p:txBody>
+          <a:bodyPr wrap="square" lIns="0" tIns="0" rIns="0" bIns="0" rtlCol="0" anchor="ctr"/>
+          <a:lstStyle/>
+          <a:p>
+            <a:pPr indent="0" marL="0">
+              <a:buNone/>
+            </a:pPr>
+            <a:r>
+              <a:rPr lang="en-US" sz="1250" b="1" dirty="0">
+                <a:solidFill>
+                  <a:srgbClr val="1E2761"/>
+                </a:solidFill>
+                <a:latin typeface="Calibri" pitchFamily="34" charset="0"/>
+                <a:ea typeface="Calibri" pitchFamily="34" charset="-122"/>
+                <a:cs typeface="Calibri" pitchFamily="34" charset="-120"/>
+              </a:rPr>
+              <a:t>🥊 Le match des « moons » (S8_P2/P3)</a:t>
+            </a:r>
+            <a:endParaRPr lang="en-US" sz="1250" dirty="0"/>
+          </a:p>
+        </p:txBody>
+      </p:sp>
+      <p:sp>
+        <p:nvSpPr>
+          <p:cNvPr id="15" name="Text 13"/>
+          <p:cNvSpPr/>
+          <p:nvPr/>
+        </p:nvSpPr>
+        <p:spPr>
+          <a:xfrm>
+            <a:off x="4992624" y="1591056"/>
+            <a:ext cx="3547872" cy="950976"/>
+          </a:xfrm>
+          <a:prstGeom prst="rect">
+            <a:avLst/>
+          </a:prstGeom>
+          <a:noFill/>
+          <a:ln/>
+        </p:spPr>
+        <p:txBody>
+          <a:bodyPr wrap="square" lIns="0" tIns="0" rIns="0" bIns="0" rtlCol="0" anchor="t"/>
+          <a:lstStyle/>
+          <a:p>
+            <a:pPr indent="0" marL="0">
+              <a:lnSpc>
+                <a:spcPct val="106000"/>
+              </a:lnSpc>
+              <a:buNone/>
+            </a:pPr>
+            <a:r>
+              <a:rPr lang="en-US" sz="1050" dirty="0">
+                <a:solidFill>
+                  <a:srgbClr val="2A3550"/>
+                </a:solidFill>
+                <a:latin typeface="Calibri" pitchFamily="34" charset="0"/>
+                <a:ea typeface="Calibri" pitchFamily="34" charset="-122"/>
+                <a:cs typeface="Calibri" pitchFamily="34" charset="-120"/>
+              </a:rPr>
+              <a:t>Deux croissants entrelacés :</a:t>
+            </a:r>
+            <a:endParaRPr lang="en-US" sz="1050" dirty="0"/>
+          </a:p>
+          <a:p>
+            <a:pPr indent="0" marL="0">
+              <a:lnSpc>
+                <a:spcPct val="106000"/>
+              </a:lnSpc>
+              <a:buNone/>
+            </a:pPr>
+            <a:r>
+              <a:rPr lang="en-US" sz="1050" b="1" dirty="0">
+                <a:solidFill>
+                  <a:srgbClr val="2A3550"/>
+                </a:solidFill>
+                <a:latin typeface="Calibri" pitchFamily="34" charset="0"/>
+                <a:ea typeface="Calibri" pitchFamily="34" charset="-122"/>
+                <a:cs typeface="Calibri" pitchFamily="34" charset="-120"/>
+              </a:rPr>
+              <a:t>KMeans les coupe de travers ❌ (blocs ronds) · DBSCAN épouse leur forme ✅ (densité)</a:t>
+            </a:r>
+            <a:endParaRPr lang="en-US" sz="1050" dirty="0"/>
+          </a:p>
+          <a:p>
+            <a:pPr indent="0" marL="0">
+              <a:lnSpc>
+                <a:spcPct val="106000"/>
+              </a:lnSpc>
+              <a:buNone/>
+            </a:pPr>
+            <a:r>
+              <a:rPr lang="en-US" sz="1000" i="1" dirty="0">
+                <a:solidFill>
+                  <a:srgbClr val="2A3550"/>
+                </a:solidFill>
+                <a:latin typeface="Calibri" pitchFamily="34" charset="0"/>
+                <a:ea typeface="Calibri" pitchFamily="34" charset="-122"/>
+                <a:cs typeface="Calibri" pitchFamily="34" charset="-120"/>
+              </a:rPr>
+              <a:t>La leçon centrale : choisir l'algo selon la FORME des données.</a:t>
+            </a:r>
+            <a:endParaRPr lang="en-US" sz="1050" dirty="0"/>
+          </a:p>
+        </p:txBody>
+      </p:sp>
+      <p:sp>
+        <p:nvSpPr>
+          <p:cNvPr id="16" name="Shape 14"/>
+          <p:cNvSpPr/>
+          <p:nvPr/>
+        </p:nvSpPr>
+        <p:spPr>
+          <a:xfrm>
+            <a:off x="4846320" y="2834640"/>
+            <a:ext cx="3840480" cy="960120"/>
+          </a:xfrm>
+          <a:prstGeom prst="roundRect">
+            <a:avLst>
+              <a:gd name="adj" fmla="val 5714"/>
+            </a:avLst>
+          </a:prstGeom>
+          <a:solidFill>
+            <a:srgbClr val="EEF4FE"/>
+          </a:solidFill>
+          <a:ln/>
+          <a:effectLst>
+            <a:outerShdw sx="100000" sy="100000" kx="0" ky="0" algn="bl" rotWithShape="0" blurRad="88900" dist="25400" dir="2700000">
+              <a:srgbClr val="000000">
+                <a:alpha val="14000"/>
+              </a:srgbClr>
+            </a:outerShdw>
+          </a:effectLst>
+        </p:spPr>
+      </p:sp>
+      <p:sp>
+        <p:nvSpPr>
+          <p:cNvPr id="17" name="Text 15"/>
+          <p:cNvSpPr/>
+          <p:nvPr/>
+        </p:nvSpPr>
+        <p:spPr>
+          <a:xfrm>
+            <a:off x="4992624" y="2944368"/>
+            <a:ext cx="3547872" cy="274320"/>
+          </a:xfrm>
+          <a:prstGeom prst="rect">
+            <a:avLst/>
+          </a:prstGeom>
+          <a:noFill/>
+          <a:ln/>
+        </p:spPr>
+        <p:txBody>
+          <a:bodyPr wrap="square" lIns="0" tIns="0" rIns="0" bIns="0" rtlCol="0" anchor="ctr"/>
+          <a:lstStyle/>
+          <a:p>
+            <a:pPr indent="0" marL="0">
+              <a:buNone/>
+            </a:pPr>
+            <a:r>
+              <a:rPr lang="en-US" sz="1250" b="1" dirty="0">
+                <a:solidFill>
+                  <a:srgbClr val="1E2761"/>
+                </a:solidFill>
+                <a:latin typeface="Calibri" pitchFamily="34" charset="0"/>
+                <a:ea typeface="Calibri" pitchFamily="34" charset="-122"/>
+                <a:cs typeface="Calibri" pitchFamily="34" charset="-120"/>
+              </a:rPr>
+              <a:t>Choisir k : coude &amp; silhouette</a:t>
+            </a:r>
+            <a:endParaRPr lang="en-US" sz="1250" dirty="0"/>
+          </a:p>
+        </p:txBody>
+      </p:sp>
+      <p:sp>
+        <p:nvSpPr>
+          <p:cNvPr id="18" name="Text 16"/>
+          <p:cNvSpPr/>
+          <p:nvPr/>
+        </p:nvSpPr>
+        <p:spPr>
+          <a:xfrm>
+            <a:off x="4992624" y="3236976"/>
+            <a:ext cx="3547872" cy="448056"/>
+          </a:xfrm>
+          <a:prstGeom prst="rect">
+            <a:avLst/>
+          </a:prstGeom>
+          <a:noFill/>
+          <a:ln/>
+        </p:spPr>
+        <p:txBody>
+          <a:bodyPr wrap="square" lIns="0" tIns="0" rIns="0" bIns="0" rtlCol="0" anchor="t"/>
+          <a:lstStyle/>
+          <a:p>
+            <a:pPr indent="0" marL="0">
+              <a:lnSpc>
+                <a:spcPct val="106000"/>
+              </a:lnSpc>
+              <a:buNone/>
+            </a:pPr>
+            <a:r>
+              <a:rPr lang="en-US" sz="1000" dirty="0">
+                <a:solidFill>
+                  <a:srgbClr val="2A3550"/>
+                </a:solidFill>
+                <a:latin typeface="Calibri" pitchFamily="34" charset="0"/>
+                <a:ea typeface="Calibri" pitchFamily="34" charset="-122"/>
+                <a:cs typeface="Calibri" pitchFamily="34" charset="-120"/>
+              </a:rPr>
+              <a:t>Coude : l'inertie (SSE) chute puis se stabilise → k au coude. Silhouette (−1 à 1) : on prend le k qui la MAXIMISE. Iris → k=3.</a:t>
+            </a:r>
+            <a:endParaRPr lang="en-US" sz="1050" dirty="0"/>
+          </a:p>
+        </p:txBody>
+      </p:sp>
+      <p:sp>
+        <p:nvSpPr>
+          <p:cNvPr id="19" name="Shape 17"/>
+          <p:cNvSpPr/>
+          <p:nvPr/>
+        </p:nvSpPr>
+        <p:spPr>
+          <a:xfrm>
+            <a:off x="4846320" y="3931920"/>
+            <a:ext cx="3840480" cy="868680"/>
+          </a:xfrm>
+          <a:prstGeom prst="roundRect">
+            <a:avLst>
+              <a:gd name="adj" fmla="val 6316"/>
+            </a:avLst>
+          </a:prstGeom>
+          <a:solidFill>
+            <a:srgbClr val="EEF4FE"/>
+          </a:solidFill>
+          <a:ln/>
+          <a:effectLst>
+            <a:outerShdw sx="100000" sy="100000" kx="0" ky="0" algn="bl" rotWithShape="0" blurRad="88900" dist="25400" dir="2700000">
+              <a:srgbClr val="000000">
+                <a:alpha val="14000"/>
+              </a:srgbClr>
+            </a:outerShdw>
+          </a:effectLst>
+        </p:spPr>
+      </p:sp>
+      <p:sp>
+        <p:nvSpPr>
+          <p:cNvPr id="20" name="Text 18"/>
+          <p:cNvSpPr/>
+          <p:nvPr/>
+        </p:nvSpPr>
+        <p:spPr>
+          <a:xfrm>
+            <a:off x="4992624" y="4041648"/>
+            <a:ext cx="3547872" cy="274320"/>
+          </a:xfrm>
+          <a:prstGeom prst="rect">
+            <a:avLst/>
+          </a:prstGeom>
+          <a:noFill/>
+          <a:ln/>
+        </p:spPr>
+        <p:txBody>
+          <a:bodyPr wrap="square" lIns="0" tIns="0" rIns="0" bIns="0" rtlCol="0" anchor="ctr"/>
+          <a:lstStyle/>
+          <a:p>
+            <a:pPr indent="0" marL="0">
+              <a:buNone/>
+            </a:pPr>
+            <a:r>
+              <a:rPr lang="en-US" sz="1250" b="1" dirty="0">
+                <a:solidFill>
+                  <a:srgbClr val="1E2761"/>
+                </a:solidFill>
+                <a:latin typeface="Calibri" pitchFamily="34" charset="0"/>
+                <a:ea typeface="Calibri" pitchFamily="34" charset="-122"/>
+                <a:cs typeface="Calibri" pitchFamily="34" charset="-120"/>
+              </a:rPr>
+              <a:t>Voir en 2D : PCA &amp; t-SNE (S8_P4)</a:t>
+            </a:r>
+            <a:endParaRPr lang="en-US" sz="1250" dirty="0"/>
+          </a:p>
+        </p:txBody>
+      </p:sp>
+      <p:sp>
+        <p:nvSpPr>
+          <p:cNvPr id="21" name="Text 19"/>
+          <p:cNvSpPr/>
+          <p:nvPr/>
+        </p:nvSpPr>
+        <p:spPr>
+          <a:xfrm>
+            <a:off x="4992624" y="4334256"/>
+            <a:ext cx="3547872" cy="356616"/>
+          </a:xfrm>
+          <a:prstGeom prst="rect">
+            <a:avLst/>
+          </a:prstGeom>
+          <a:noFill/>
+          <a:ln/>
+        </p:spPr>
+        <p:txBody>
+          <a:bodyPr wrap="square" lIns="0" tIns="0" rIns="0" bIns="0" rtlCol="0" anchor="t"/>
+          <a:lstStyle/>
+          <a:p>
+            <a:pPr indent="0" marL="0">
+              <a:lnSpc>
+                <a:spcPct val="106000"/>
+              </a:lnSpc>
+              <a:buNone/>
+            </a:pPr>
+            <a:r>
+              <a:rPr lang="en-US" sz="1000" dirty="0">
+                <a:solidFill>
+                  <a:srgbClr val="2A3550"/>
+                </a:solidFill>
+                <a:latin typeface="Calibri" pitchFamily="34" charset="0"/>
+                <a:ea typeface="Calibri" pitchFamily="34" charset="-122"/>
+                <a:cs typeface="Calibri" pitchFamily="34" charset="-120"/>
+              </a:rPr>
+              <a:t>PCA : projection linéaire (95.8 % de variance gardée sur Iris !) · t-SNE : voisinages locaux, visualisation only.</a:t>
+            </a:r>
+            <a:endParaRPr lang="en-US" sz="1050" dirty="0"/>
+          </a:p>
+        </p:txBody>
+      </p:sp>
+    </p:spTree>
+  </p:cSld>
+  <p:clrMapOvr>
+    <a:masterClrMapping/>
+  </p:clrMapOvr>
+</p:sld>
+</file>
+
+<file path=ppt/slides/slide42.xml><?xml version="1.0" encoding="utf-8"?>
+<p:sld xmlns:a="http://schemas.openxmlformats.org/drawingml/2006/main" xmlns:r="http://schemas.openxmlformats.org/officeDocument/2006/relationships" xmlns:p="http://schemas.openxmlformats.org/presentationml/2006/main">
+  <p:cSld name="Slide 42">
+    <p:bg>
+      <p:bgPr>
+        <a:solidFill>
+          <a:srgbClr val="FFFFFF"/>
+        </a:solidFill>
+      </p:bgPr>
+    </p:bg>
+    <p:spTree>
+      <p:nvGrpSpPr>
+        <p:cNvPr id="1" name=""/>
+        <p:cNvGrpSpPr/>
+        <p:nvPr/>
+      </p:nvGrpSpPr>
+      <p:grpSpPr>
+        <a:xfrm>
+          <a:off x="0" y="0"/>
+          <a:ext cx="0" cy="0"/>
+          <a:chOff x="0" y="0"/>
+          <a:chExt cx="0" cy="0"/>
+        </a:xfrm>
+      </p:grpSpPr>
+      <p:sp>
+        <p:nvSpPr>
+          <p:cNvPr id="2" name="Text 0"/>
+          <p:cNvSpPr/>
+          <p:nvPr/>
+        </p:nvSpPr>
+        <p:spPr>
+          <a:xfrm>
+            <a:off x="457200" y="201168"/>
+            <a:ext cx="8229600" cy="256032"/>
+          </a:xfrm>
+          <a:prstGeom prst="rect">
+            <a:avLst/>
+          </a:prstGeom>
+          <a:noFill/>
+          <a:ln/>
+        </p:spPr>
+        <p:txBody>
+          <a:bodyPr wrap="square" lIns="0" tIns="0" rIns="0" bIns="0" rtlCol="0" anchor="ctr"/>
+          <a:lstStyle/>
+          <a:p>
+            <a:pPr indent="0" marL="0">
+              <a:buNone/>
+            </a:pPr>
+            <a:r>
+              <a:rPr lang="en-US" sz="1100" b="1" spc="200" kern="0" dirty="0">
+                <a:solidFill>
+                  <a:srgbClr val="017A61"/>
+                </a:solidFill>
+                <a:latin typeface="Calibri" pitchFamily="34" charset="0"/>
+                <a:ea typeface="Calibri" pitchFamily="34" charset="-122"/>
+                <a:cs typeface="Calibri" pitchFamily="34" charset="-120"/>
+              </a:rPr>
+              <a:t>LE MUR DE LA HONTE (ON A TOUS FAIT CES ERREURS)</a:t>
+            </a:r>
+            <a:endParaRPr lang="en-US" sz="1100" dirty="0"/>
+          </a:p>
+        </p:txBody>
+      </p:sp>
+      <p:sp>
+        <p:nvSpPr>
+          <p:cNvPr id="3" name="Text 1"/>
+          <p:cNvSpPr/>
+          <p:nvPr/>
+        </p:nvSpPr>
+        <p:spPr>
+          <a:xfrm>
+            <a:off x="457200" y="438912"/>
+            <a:ext cx="8229600" cy="566928"/>
+          </a:xfrm>
+          <a:prstGeom prst="rect">
+            <a:avLst/>
+          </a:prstGeom>
+          <a:noFill/>
+          <a:ln/>
+        </p:spPr>
+        <p:txBody>
+          <a:bodyPr wrap="square" lIns="0" tIns="0" rIns="0" bIns="0" rtlCol="0" anchor="ctr"/>
+          <a:lstStyle/>
+          <a:p>
+            <a:pPr indent="0" marL="0">
+              <a:buNone/>
+            </a:pPr>
+            <a:r>
+              <a:rPr lang="en-US" sz="2700" b="1" dirty="0">
+                <a:solidFill>
+                  <a:srgbClr val="1E2761"/>
+                </a:solidFill>
+                <a:latin typeface="Calibri" pitchFamily="34" charset="0"/>
+                <a:ea typeface="Calibri" pitchFamily="34" charset="-122"/>
+                <a:cs typeface="Calibri" pitchFamily="34" charset="-120"/>
+              </a:rPr>
+              <a:t>Les 8 pièges célèbres du cours 🏆</a:t>
+            </a:r>
+            <a:endParaRPr lang="en-US" sz="2700" dirty="0"/>
+          </a:p>
+        </p:txBody>
+      </p:sp>
+      <p:sp>
+        <p:nvSpPr>
+          <p:cNvPr id="4" name="Shape 2"/>
+          <p:cNvSpPr/>
+          <p:nvPr/>
+        </p:nvSpPr>
+        <p:spPr>
+          <a:xfrm>
+            <a:off x="457200" y="1188720"/>
+            <a:ext cx="4041648" cy="804672"/>
+          </a:xfrm>
+          <a:prstGeom prst="roundRect">
+            <a:avLst>
+              <a:gd name="adj" fmla="val 6818"/>
+            </a:avLst>
+          </a:prstGeom>
+          <a:solidFill>
+            <a:srgbClr val="EEF4FE"/>
+          </a:solidFill>
+          <a:ln/>
+          <a:effectLst>
+            <a:outerShdw sx="100000" sy="100000" kx="0" ky="0" algn="bl" rotWithShape="0" blurRad="88900" dist="25400" dir="2700000">
+              <a:srgbClr val="000000">
+                <a:alpha val="14000"/>
+              </a:srgbClr>
+            </a:outerShdw>
+          </a:effectLst>
+        </p:spPr>
+      </p:sp>
+      <p:sp>
+        <p:nvSpPr>
+          <p:cNvPr id="5" name="Shape 3"/>
+          <p:cNvSpPr/>
+          <p:nvPr/>
+        </p:nvSpPr>
+        <p:spPr>
+          <a:xfrm>
+            <a:off x="566928" y="1426464"/>
+            <a:ext cx="329184" cy="329184"/>
+          </a:xfrm>
+          <a:prstGeom prst="ellipse">
+            <a:avLst/>
+          </a:prstGeom>
+          <a:solidFill>
+            <a:srgbClr val="D64550"/>
+          </a:solidFill>
+          <a:ln/>
+        </p:spPr>
+      </p:sp>
+      <p:sp>
+        <p:nvSpPr>
+          <p:cNvPr id="6" name="Text 4"/>
+          <p:cNvSpPr/>
+          <p:nvPr/>
+        </p:nvSpPr>
+        <p:spPr>
+          <a:xfrm>
+            <a:off x="566928" y="1417320"/>
+            <a:ext cx="329184" cy="329184"/>
+          </a:xfrm>
+          <a:prstGeom prst="rect">
+            <a:avLst/>
+          </a:prstGeom>
+          <a:noFill/>
+          <a:ln/>
+        </p:spPr>
+        <p:txBody>
+          <a:bodyPr wrap="square" lIns="0" tIns="0" rIns="0" bIns="0" rtlCol="0" anchor="ctr"/>
+          <a:lstStyle/>
+          <a:p>
+            <a:pPr algn="ctr" indent="0" marL="0">
+              <a:buNone/>
+            </a:pPr>
+            <a:r>
+              <a:rPr lang="en-US" sz="1300" b="1" dirty="0">
+                <a:solidFill>
+                  <a:srgbClr val="FFFFFF"/>
+                </a:solidFill>
+                <a:latin typeface="Calibri" pitchFamily="34" charset="0"/>
+                <a:ea typeface="Calibri" pitchFamily="34" charset="-122"/>
+                <a:cs typeface="Calibri" pitchFamily="34" charset="-120"/>
+              </a:rPr>
+              <a:t>1</a:t>
+            </a:r>
+            <a:endParaRPr lang="en-US" sz="1300" dirty="0"/>
+          </a:p>
+        </p:txBody>
+      </p:sp>
+      <p:sp>
+        <p:nvSpPr>
+          <p:cNvPr id="7" name="Text 5"/>
+          <p:cNvSpPr/>
+          <p:nvPr/>
+        </p:nvSpPr>
+        <p:spPr>
+          <a:xfrm>
+            <a:off x="1005840" y="1261872"/>
+            <a:ext cx="3401568" cy="685800"/>
+          </a:xfrm>
+          <a:prstGeom prst="rect">
+            <a:avLst/>
+          </a:prstGeom>
+          <a:noFill/>
+          <a:ln/>
+        </p:spPr>
+        <p:txBody>
+          <a:bodyPr wrap="square" lIns="0" tIns="0" rIns="0" bIns="0" rtlCol="0" anchor="t"/>
+          <a:lstStyle/>
+          <a:p>
+            <a:pPr indent="0" marL="0">
+              <a:lnSpc>
+                <a:spcPct val="105000"/>
+              </a:lnSpc>
+              <a:buNone/>
+            </a:pPr>
+            <a:r>
+              <a:rPr lang="en-US" sz="950" b="1" dirty="0">
+                <a:solidFill>
+                  <a:srgbClr val="1E2761"/>
+                </a:solidFill>
+                <a:latin typeface="Courier New" pitchFamily="34" charset="0"/>
+                <a:ea typeface="Courier New" pitchFamily="34" charset="-122"/>
+                <a:cs typeface="Courier New" pitchFamily="34" charset="-120"/>
+              </a:rPr>
+              <a:t>fit(X_test, y_test)</a:t>
+            </a:r>
+            <a:endParaRPr lang="en-US" sz="950" dirty="0"/>
+          </a:p>
+          <a:p>
+            <a:pPr indent="0" marL="0">
+              <a:lnSpc>
+                <a:spcPct val="105000"/>
+              </a:lnSpc>
+              <a:buNone/>
+            </a:pPr>
+            <a:r>
+              <a:rPr lang="en-US" sz="900" dirty="0">
+                <a:solidFill>
+                  <a:srgbClr val="2A3550"/>
+                </a:solidFill>
+                <a:latin typeface="Calibri" pitchFamily="34" charset="0"/>
+                <a:ea typeface="Calibri" pitchFamily="34" charset="-122"/>
+                <a:cs typeface="Calibri" pitchFamily="34" charset="-120"/>
+              </a:rPr>
+              <a:t>entraîné sur le test = l'élève avec les corrigés (S2_P3)</a:t>
+            </a:r>
+            <a:endParaRPr lang="en-US" sz="950" dirty="0"/>
+          </a:p>
+        </p:txBody>
+      </p:sp>
+      <p:sp>
+        <p:nvSpPr>
+          <p:cNvPr id="8" name="Shape 6"/>
+          <p:cNvSpPr/>
+          <p:nvPr/>
+        </p:nvSpPr>
+        <p:spPr>
+          <a:xfrm>
+            <a:off x="4681728" y="1188720"/>
+            <a:ext cx="4041648" cy="804672"/>
+          </a:xfrm>
+          <a:prstGeom prst="roundRect">
+            <a:avLst>
+              <a:gd name="adj" fmla="val 6818"/>
+            </a:avLst>
+          </a:prstGeom>
+          <a:solidFill>
+            <a:srgbClr val="EEF4FE"/>
+          </a:solidFill>
+          <a:ln/>
+          <a:effectLst>
+            <a:outerShdw sx="100000" sy="100000" kx="0" ky="0" algn="bl" rotWithShape="0" blurRad="88900" dist="25400" dir="2700000">
+              <a:srgbClr val="000000">
+                <a:alpha val="14000"/>
+              </a:srgbClr>
+            </a:outerShdw>
+          </a:effectLst>
+        </p:spPr>
+      </p:sp>
+      <p:sp>
+        <p:nvSpPr>
+          <p:cNvPr id="9" name="Shape 7"/>
+          <p:cNvSpPr/>
+          <p:nvPr/>
+        </p:nvSpPr>
+        <p:spPr>
+          <a:xfrm>
+            <a:off x="4791456" y="1426464"/>
+            <a:ext cx="329184" cy="329184"/>
+          </a:xfrm>
+          <a:prstGeom prst="ellipse">
+            <a:avLst/>
+          </a:prstGeom>
+          <a:solidFill>
+            <a:srgbClr val="D64550"/>
+          </a:solidFill>
+          <a:ln/>
+        </p:spPr>
+      </p:sp>
+      <p:sp>
+        <p:nvSpPr>
+          <p:cNvPr id="10" name="Text 8"/>
+          <p:cNvSpPr/>
+          <p:nvPr/>
+        </p:nvSpPr>
+        <p:spPr>
+          <a:xfrm>
+            <a:off x="4791456" y="1417320"/>
+            <a:ext cx="329184" cy="329184"/>
+          </a:xfrm>
+          <a:prstGeom prst="rect">
+            <a:avLst/>
+          </a:prstGeom>
+          <a:noFill/>
+          <a:ln/>
+        </p:spPr>
+        <p:txBody>
+          <a:bodyPr wrap="square" lIns="0" tIns="0" rIns="0" bIns="0" rtlCol="0" anchor="ctr"/>
+          <a:lstStyle/>
+          <a:p>
+            <a:pPr algn="ctr" indent="0" marL="0">
+              <a:buNone/>
+            </a:pPr>
+            <a:r>
+              <a:rPr lang="en-US" sz="1300" b="1" dirty="0">
+                <a:solidFill>
+                  <a:srgbClr val="FFFFFF"/>
+                </a:solidFill>
+                <a:latin typeface="Calibri" pitchFamily="34" charset="0"/>
+                <a:ea typeface="Calibri" pitchFamily="34" charset="-122"/>
+                <a:cs typeface="Calibri" pitchFamily="34" charset="-120"/>
+              </a:rPr>
+              <a:t>2</a:t>
+            </a:r>
+            <a:endParaRPr lang="en-US" sz="1300" dirty="0"/>
+          </a:p>
+        </p:txBody>
+      </p:sp>
+      <p:sp>
+        <p:nvSpPr>
+          <p:cNvPr id="11" name="Text 9"/>
+          <p:cNvSpPr/>
+          <p:nvPr/>
+        </p:nvSpPr>
+        <p:spPr>
+          <a:xfrm>
+            <a:off x="5230368" y="1261872"/>
+            <a:ext cx="3401568" cy="685800"/>
+          </a:xfrm>
+          <a:prstGeom prst="rect">
+            <a:avLst/>
+          </a:prstGeom>
+          <a:noFill/>
+          <a:ln/>
+        </p:spPr>
+        <p:txBody>
+          <a:bodyPr wrap="square" lIns="0" tIns="0" rIns="0" bIns="0" rtlCol="0" anchor="t"/>
+          <a:lstStyle/>
+          <a:p>
+            <a:pPr indent="0" marL="0">
+              <a:lnSpc>
+                <a:spcPct val="105000"/>
+              </a:lnSpc>
+              <a:buNone/>
+            </a:pPr>
+            <a:r>
+              <a:rPr lang="en-US" sz="950" b="1" dirty="0">
+                <a:solidFill>
+                  <a:srgbClr val="1E2761"/>
+                </a:solidFill>
+                <a:latin typeface="Courier New" pitchFamily="34" charset="0"/>
+                <a:ea typeface="Courier New" pitchFamily="34" charset="-122"/>
+                <a:cs typeface="Courier New" pitchFamily="34" charset="-120"/>
+              </a:rPr>
+              <a:t>classification_report(y_pred, y_test)</a:t>
+            </a:r>
+            <a:endParaRPr lang="en-US" sz="950" dirty="0"/>
+          </a:p>
+          <a:p>
+            <a:pPr indent="0" marL="0">
+              <a:lnSpc>
+                <a:spcPct val="105000"/>
+              </a:lnSpc>
+              <a:buNone/>
+            </a:pPr>
+            <a:r>
+              <a:rPr lang="en-US" sz="900" dirty="0">
+                <a:solidFill>
+                  <a:srgbClr val="2A3550"/>
+                </a:solidFill>
+                <a:latin typeface="Calibri" pitchFamily="34" charset="0"/>
+                <a:ea typeface="Calibri" pitchFamily="34" charset="-122"/>
+                <a:cs typeface="Calibri" pitchFamily="34" charset="-120"/>
+              </a:rPr>
+              <a:t>ordre inversé → précision et rappel ÉCHANGÉS (S3)</a:t>
+            </a:r>
+            <a:endParaRPr lang="en-US" sz="950" dirty="0"/>
+          </a:p>
+        </p:txBody>
+      </p:sp>
+      <p:sp>
+        <p:nvSpPr>
+          <p:cNvPr id="12" name="Shape 10"/>
+          <p:cNvSpPr/>
+          <p:nvPr/>
+        </p:nvSpPr>
+        <p:spPr>
+          <a:xfrm>
+            <a:off x="457200" y="2103120"/>
+            <a:ext cx="4041648" cy="804672"/>
+          </a:xfrm>
+          <a:prstGeom prst="roundRect">
+            <a:avLst>
+              <a:gd name="adj" fmla="val 6818"/>
+            </a:avLst>
+          </a:prstGeom>
+          <a:solidFill>
+            <a:srgbClr val="EEF4FE"/>
+          </a:solidFill>
+          <a:ln/>
+          <a:effectLst>
+            <a:outerShdw sx="100000" sy="100000" kx="0" ky="0" algn="bl" rotWithShape="0" blurRad="88900" dist="25400" dir="2700000">
+              <a:srgbClr val="000000">
+                <a:alpha val="14000"/>
+              </a:srgbClr>
+            </a:outerShdw>
+          </a:effectLst>
+        </p:spPr>
+      </p:sp>
+      <p:sp>
+        <p:nvSpPr>
+          <p:cNvPr id="13" name="Shape 11"/>
+          <p:cNvSpPr/>
+          <p:nvPr/>
+        </p:nvSpPr>
+        <p:spPr>
+          <a:xfrm>
+            <a:off x="566928" y="2340864"/>
+            <a:ext cx="329184" cy="329184"/>
+          </a:xfrm>
+          <a:prstGeom prst="ellipse">
+            <a:avLst/>
+          </a:prstGeom>
+          <a:solidFill>
+            <a:srgbClr val="D64550"/>
+          </a:solidFill>
+          <a:ln/>
+        </p:spPr>
+      </p:sp>
+      <p:sp>
+        <p:nvSpPr>
+          <p:cNvPr id="14" name="Text 12"/>
+          <p:cNvSpPr/>
+          <p:nvPr/>
+        </p:nvSpPr>
+        <p:spPr>
+          <a:xfrm>
+            <a:off x="566928" y="2331720"/>
+            <a:ext cx="329184" cy="329184"/>
+          </a:xfrm>
+          <a:prstGeom prst="rect">
+            <a:avLst/>
+          </a:prstGeom>
+          <a:noFill/>
+          <a:ln/>
+        </p:spPr>
+        <p:txBody>
+          <a:bodyPr wrap="square" lIns="0" tIns="0" rIns="0" bIns="0" rtlCol="0" anchor="ctr"/>
+          <a:lstStyle/>
+          <a:p>
+            <a:pPr algn="ctr" indent="0" marL="0">
+              <a:buNone/>
+            </a:pPr>
+            <a:r>
+              <a:rPr lang="en-US" sz="1300" b="1" dirty="0">
+                <a:solidFill>
+                  <a:srgbClr val="FFFFFF"/>
+                </a:solidFill>
+                <a:latin typeface="Calibri" pitchFamily="34" charset="0"/>
+                <a:ea typeface="Calibri" pitchFamily="34" charset="-122"/>
+                <a:cs typeface="Calibri" pitchFamily="34" charset="-120"/>
+              </a:rPr>
+              <a:t>3</a:t>
+            </a:r>
+            <a:endParaRPr lang="en-US" sz="1300" dirty="0"/>
+          </a:p>
+        </p:txBody>
+      </p:sp>
+      <p:sp>
+        <p:nvSpPr>
+          <p:cNvPr id="15" name="Text 13"/>
+          <p:cNvSpPr/>
+          <p:nvPr/>
+        </p:nvSpPr>
+        <p:spPr>
+          <a:xfrm>
+            <a:off x="1005840" y="2176272"/>
+            <a:ext cx="3401568" cy="685800"/>
+          </a:xfrm>
+          <a:prstGeom prst="rect">
+            <a:avLst/>
+          </a:prstGeom>
+          <a:noFill/>
+          <a:ln/>
+        </p:spPr>
+        <p:txBody>
+          <a:bodyPr wrap="square" lIns="0" tIns="0" rIns="0" bIns="0" rtlCol="0" anchor="t"/>
+          <a:lstStyle/>
+          <a:p>
+            <a:pPr indent="0" marL="0">
+              <a:lnSpc>
+                <a:spcPct val="105000"/>
+              </a:lnSpc>
+              <a:buNone/>
+            </a:pPr>
+            <a:r>
+              <a:rPr lang="en-US" sz="950" b="1" dirty="0">
+                <a:solidFill>
+                  <a:srgbClr val="1E2761"/>
+                </a:solidFill>
+                <a:latin typeface="Courier New" pitchFamily="34" charset="0"/>
+                <a:ea typeface="Courier New" pitchFamily="34" charset="-122"/>
+                <a:cs typeface="Courier New" pitchFamily="34" charset="-120"/>
+              </a:rPr>
+              <a:t>Le kernel qui « sauve »</a:t>
+            </a:r>
+            <a:endParaRPr lang="en-US" sz="950" dirty="0"/>
+          </a:p>
+          <a:p>
+            <a:pPr indent="0" marL="0">
+              <a:lnSpc>
+                <a:spcPct val="105000"/>
+              </a:lnSpc>
+              <a:buNone/>
+            </a:pPr>
+            <a:r>
+              <a:rPr lang="en-US" sz="900" dirty="0">
+                <a:solidFill>
+                  <a:srgbClr val="2A3550"/>
+                </a:solidFill>
+                <a:latin typeface="Calibri" pitchFamily="34" charset="0"/>
+                <a:ea typeface="Calibri" pitchFamily="34" charset="-122"/>
+                <a:cs typeface="Calibri" pitchFamily="34" charset="-120"/>
+              </a:rPr>
+              <a:t>imports supprimés mais encore en mémoire → Restart &amp; Run All ! (S3_P4)</a:t>
+            </a:r>
+            <a:endParaRPr lang="en-US" sz="950" dirty="0"/>
+          </a:p>
+        </p:txBody>
+      </p:sp>
+      <p:sp>
+        <p:nvSpPr>
+          <p:cNvPr id="16" name="Shape 14"/>
+          <p:cNvSpPr/>
+          <p:nvPr/>
+        </p:nvSpPr>
+        <p:spPr>
+          <a:xfrm>
+            <a:off x="4681728" y="2103120"/>
+            <a:ext cx="4041648" cy="804672"/>
+          </a:xfrm>
+          <a:prstGeom prst="roundRect">
+            <a:avLst>
+              <a:gd name="adj" fmla="val 6818"/>
+            </a:avLst>
+          </a:prstGeom>
+          <a:solidFill>
+            <a:srgbClr val="EEF4FE"/>
+          </a:solidFill>
+          <a:ln/>
+          <a:effectLst>
+            <a:outerShdw sx="100000" sy="100000" kx="0" ky="0" algn="bl" rotWithShape="0" blurRad="88900" dist="25400" dir="2700000">
+              <a:srgbClr val="000000">
+                <a:alpha val="14000"/>
+              </a:srgbClr>
+            </a:outerShdw>
+          </a:effectLst>
+        </p:spPr>
+      </p:sp>
+      <p:sp>
+        <p:nvSpPr>
+          <p:cNvPr id="17" name="Shape 15"/>
+          <p:cNvSpPr/>
+          <p:nvPr/>
+        </p:nvSpPr>
+        <p:spPr>
+          <a:xfrm>
+            <a:off x="4791456" y="2340864"/>
+            <a:ext cx="329184" cy="329184"/>
+          </a:xfrm>
+          <a:prstGeom prst="ellipse">
+            <a:avLst/>
+          </a:prstGeom>
+          <a:solidFill>
+            <a:srgbClr val="D64550"/>
+          </a:solidFill>
+          <a:ln/>
+        </p:spPr>
+      </p:sp>
+      <p:sp>
+        <p:nvSpPr>
+          <p:cNvPr id="18" name="Text 16"/>
+          <p:cNvSpPr/>
+          <p:nvPr/>
+        </p:nvSpPr>
+        <p:spPr>
+          <a:xfrm>
+            <a:off x="4791456" y="2331720"/>
+            <a:ext cx="329184" cy="329184"/>
+          </a:xfrm>
+          <a:prstGeom prst="rect">
+            <a:avLst/>
+          </a:prstGeom>
+          <a:noFill/>
+          <a:ln/>
+        </p:spPr>
+        <p:txBody>
+          <a:bodyPr wrap="square" lIns="0" tIns="0" rIns="0" bIns="0" rtlCol="0" anchor="ctr"/>
+          <a:lstStyle/>
+          <a:p>
+            <a:pPr algn="ctr" indent="0" marL="0">
+              <a:buNone/>
+            </a:pPr>
+            <a:r>
+              <a:rPr lang="en-US" sz="1300" b="1" dirty="0">
+                <a:solidFill>
+                  <a:srgbClr val="FFFFFF"/>
+                </a:solidFill>
+                <a:latin typeface="Calibri" pitchFamily="34" charset="0"/>
+                <a:ea typeface="Calibri" pitchFamily="34" charset="-122"/>
+                <a:cs typeface="Calibri" pitchFamily="34" charset="-120"/>
+              </a:rPr>
+              <a:t>4</a:t>
+            </a:r>
+            <a:endParaRPr lang="en-US" sz="1300" dirty="0"/>
+          </a:p>
+        </p:txBody>
+      </p:sp>
+      <p:sp>
+        <p:nvSpPr>
+          <p:cNvPr id="19" name="Text 17"/>
+          <p:cNvSpPr/>
+          <p:nvPr/>
+        </p:nvSpPr>
+        <p:spPr>
+          <a:xfrm>
+            <a:off x="5230368" y="2176272"/>
+            <a:ext cx="3401568" cy="685800"/>
+          </a:xfrm>
+          <a:prstGeom prst="rect">
+            <a:avLst/>
+          </a:prstGeom>
+          <a:noFill/>
+          <a:ln/>
+        </p:spPr>
+        <p:txBody>
+          <a:bodyPr wrap="square" lIns="0" tIns="0" rIns="0" bIns="0" rtlCol="0" anchor="t"/>
+          <a:lstStyle/>
+          <a:p>
+            <a:pPr indent="0" marL="0">
+              <a:lnSpc>
+                <a:spcPct val="105000"/>
+              </a:lnSpc>
+              <a:buNone/>
+            </a:pPr>
+            <a:r>
+              <a:rPr lang="en-US" sz="950" b="1" dirty="0">
+                <a:solidFill>
+                  <a:srgbClr val="1E2761"/>
+                </a:solidFill>
+                <a:latin typeface="Courier New" pitchFamily="34" charset="0"/>
+                <a:ea typeface="Courier New" pitchFamily="34" charset="-122"/>
+                <a:cs typeface="Courier New" pitchFamily="34" charset="-120"/>
+              </a:rPr>
+              <a:t>price / 1e6 exécuté 2 fois</a:t>
+            </a:r>
+            <a:endParaRPr lang="en-US" sz="950" dirty="0"/>
+          </a:p>
+          <a:p>
+            <a:pPr indent="0" marL="0">
+              <a:lnSpc>
+                <a:spcPct val="105000"/>
+              </a:lnSpc>
+              <a:buNone/>
+            </a:pPr>
+            <a:r>
+              <a:rPr lang="en-US" sz="900" dirty="0">
+                <a:solidFill>
+                  <a:srgbClr val="2A3550"/>
+                </a:solidFill>
+                <a:latin typeface="Calibri" pitchFamily="34" charset="0"/>
+                <a:ea typeface="Calibri" pitchFamily="34" charset="-122"/>
+                <a:cs typeface="Calibri" pitchFamily="34" charset="-120"/>
+              </a:rPr>
+              <a:t>cellule non-idempotente → tous les résultats faussés (S1_P2)</a:t>
+            </a:r>
+            <a:endParaRPr lang="en-US" sz="950" dirty="0"/>
+          </a:p>
+        </p:txBody>
+      </p:sp>
+      <p:sp>
+        <p:nvSpPr>
+          <p:cNvPr id="20" name="Shape 18"/>
+          <p:cNvSpPr/>
+          <p:nvPr/>
+        </p:nvSpPr>
+        <p:spPr>
+          <a:xfrm>
+            <a:off x="457200" y="3017520"/>
+            <a:ext cx="4041648" cy="804672"/>
+          </a:xfrm>
+          <a:prstGeom prst="roundRect">
+            <a:avLst>
+              <a:gd name="adj" fmla="val 6818"/>
+            </a:avLst>
+          </a:prstGeom>
+          <a:solidFill>
+            <a:srgbClr val="EEF4FE"/>
+          </a:solidFill>
+          <a:ln/>
+          <a:effectLst>
+            <a:outerShdw sx="100000" sy="100000" kx="0" ky="0" algn="bl" rotWithShape="0" blurRad="88900" dist="25400" dir="2700000">
+              <a:srgbClr val="000000">
+                <a:alpha val="14000"/>
+              </a:srgbClr>
+            </a:outerShdw>
+          </a:effectLst>
+        </p:spPr>
+      </p:sp>
+      <p:sp>
+        <p:nvSpPr>
+          <p:cNvPr id="21" name="Shape 19"/>
+          <p:cNvSpPr/>
+          <p:nvPr/>
+        </p:nvSpPr>
+        <p:spPr>
+          <a:xfrm>
+            <a:off x="566928" y="3255264"/>
+            <a:ext cx="329184" cy="329184"/>
+          </a:xfrm>
+          <a:prstGeom prst="ellipse">
+            <a:avLst/>
+          </a:prstGeom>
+          <a:solidFill>
+            <a:srgbClr val="D64550"/>
+          </a:solidFill>
+          <a:ln/>
+        </p:spPr>
+      </p:sp>
+      <p:sp>
+        <p:nvSpPr>
+          <p:cNvPr id="22" name="Text 20"/>
+          <p:cNvSpPr/>
+          <p:nvPr/>
+        </p:nvSpPr>
+        <p:spPr>
+          <a:xfrm>
+            <a:off x="566928" y="3246120"/>
+            <a:ext cx="329184" cy="329184"/>
+          </a:xfrm>
+          <a:prstGeom prst="rect">
+            <a:avLst/>
+          </a:prstGeom>
+          <a:noFill/>
+          <a:ln/>
+        </p:spPr>
+        <p:txBody>
+          <a:bodyPr wrap="square" lIns="0" tIns="0" rIns="0" bIns="0" rtlCol="0" anchor="ctr"/>
+          <a:lstStyle/>
+          <a:p>
+            <a:pPr algn="ctr" indent="0" marL="0">
+              <a:buNone/>
+            </a:pPr>
+            <a:r>
+              <a:rPr lang="en-US" sz="1300" b="1" dirty="0">
+                <a:solidFill>
+                  <a:srgbClr val="FFFFFF"/>
+                </a:solidFill>
+                <a:latin typeface="Calibri" pitchFamily="34" charset="0"/>
+                <a:ea typeface="Calibri" pitchFamily="34" charset="-122"/>
+                <a:cs typeface="Calibri" pitchFamily="34" charset="-120"/>
+              </a:rPr>
+              <a:t>5</a:t>
+            </a:r>
+            <a:endParaRPr lang="en-US" sz="1300" dirty="0"/>
+          </a:p>
+        </p:txBody>
+      </p:sp>
+      <p:sp>
+        <p:nvSpPr>
+          <p:cNvPr id="23" name="Text 21"/>
+          <p:cNvSpPr/>
+          <p:nvPr/>
+        </p:nvSpPr>
+        <p:spPr>
+          <a:xfrm>
+            <a:off x="1005840" y="3090672"/>
+            <a:ext cx="3401568" cy="685800"/>
+          </a:xfrm>
+          <a:prstGeom prst="rect">
+            <a:avLst/>
+          </a:prstGeom>
+          <a:noFill/>
+          <a:ln/>
+        </p:spPr>
+        <p:txBody>
+          <a:bodyPr wrap="square" lIns="0" tIns="0" rIns="0" bIns="0" rtlCol="0" anchor="t"/>
+          <a:lstStyle/>
+          <a:p>
+            <a:pPr indent="0" marL="0">
+              <a:lnSpc>
+                <a:spcPct val="105000"/>
+              </a:lnSpc>
+              <a:buNone/>
+            </a:pPr>
+            <a:r>
+              <a:rPr lang="en-US" sz="950" b="1" dirty="0">
+                <a:solidFill>
+                  <a:srgbClr val="1E2761"/>
+                </a:solidFill>
+                <a:latin typeface="Courier New" pitchFamily="34" charset="0"/>
+                <a:ea typeface="Courier New" pitchFamily="34" charset="-122"/>
+                <a:cs typeface="Courier New" pitchFamily="34" charset="-120"/>
+              </a:rPr>
+              <a:t>b = a  sur une liste</a:t>
+            </a:r>
+            <a:endParaRPr lang="en-US" sz="950" dirty="0"/>
+          </a:p>
+          <a:p>
+            <a:pPr indent="0" marL="0">
+              <a:lnSpc>
+                <a:spcPct val="105000"/>
+              </a:lnSpc>
+              <a:buNone/>
+            </a:pPr>
+            <a:r>
+              <a:rPr lang="en-US" sz="900" dirty="0">
+                <a:solidFill>
+                  <a:srgbClr val="2A3550"/>
+                </a:solidFill>
+                <a:latin typeface="Calibri" pitchFamily="34" charset="0"/>
+                <a:ea typeface="Calibri" pitchFamily="34" charset="-122"/>
+                <a:cs typeface="Calibri" pitchFamily="34" charset="-120"/>
+              </a:rPr>
+              <a:t>pas une copie ! .copy() sinon modifications partagées (day2)</a:t>
+            </a:r>
+            <a:endParaRPr lang="en-US" sz="950" dirty="0"/>
+          </a:p>
+        </p:txBody>
+      </p:sp>
+      <p:sp>
+        <p:nvSpPr>
+          <p:cNvPr id="24" name="Shape 22"/>
+          <p:cNvSpPr/>
+          <p:nvPr/>
+        </p:nvSpPr>
+        <p:spPr>
+          <a:xfrm>
+            <a:off x="4681728" y="3017520"/>
+            <a:ext cx="4041648" cy="804672"/>
+          </a:xfrm>
+          <a:prstGeom prst="roundRect">
+            <a:avLst>
+              <a:gd name="adj" fmla="val 6818"/>
+            </a:avLst>
+          </a:prstGeom>
+          <a:solidFill>
+            <a:srgbClr val="EEF4FE"/>
+          </a:solidFill>
+          <a:ln/>
+          <a:effectLst>
+            <a:outerShdw sx="100000" sy="100000" kx="0" ky="0" algn="bl" rotWithShape="0" blurRad="88900" dist="25400" dir="2700000">
+              <a:srgbClr val="000000">
+                <a:alpha val="14000"/>
+              </a:srgbClr>
+            </a:outerShdw>
+          </a:effectLst>
+        </p:spPr>
+      </p:sp>
+      <p:sp>
+        <p:nvSpPr>
+          <p:cNvPr id="25" name="Shape 23"/>
+          <p:cNvSpPr/>
+          <p:nvPr/>
+        </p:nvSpPr>
+        <p:spPr>
+          <a:xfrm>
+            <a:off x="4791456" y="3255264"/>
+            <a:ext cx="329184" cy="329184"/>
+          </a:xfrm>
+          <a:prstGeom prst="ellipse">
+            <a:avLst/>
+          </a:prstGeom>
+          <a:solidFill>
+            <a:srgbClr val="D64550"/>
+          </a:solidFill>
+          <a:ln/>
+        </p:spPr>
+      </p:sp>
+      <p:sp>
+        <p:nvSpPr>
+          <p:cNvPr id="26" name="Text 24"/>
+          <p:cNvSpPr/>
+          <p:nvPr/>
+        </p:nvSpPr>
+        <p:spPr>
+          <a:xfrm>
+            <a:off x="4791456" y="3246120"/>
+            <a:ext cx="329184" cy="329184"/>
+          </a:xfrm>
+          <a:prstGeom prst="rect">
+            <a:avLst/>
+          </a:prstGeom>
+          <a:noFill/>
+          <a:ln/>
+        </p:spPr>
+        <p:txBody>
+          <a:bodyPr wrap="square" lIns="0" tIns="0" rIns="0" bIns="0" rtlCol="0" anchor="ctr"/>
+          <a:lstStyle/>
+          <a:p>
+            <a:pPr algn="ctr" indent="0" marL="0">
+              <a:buNone/>
+            </a:pPr>
+            <a:r>
+              <a:rPr lang="en-US" sz="1300" b="1" dirty="0">
+                <a:solidFill>
+                  <a:srgbClr val="FFFFFF"/>
+                </a:solidFill>
+                <a:latin typeface="Calibri" pitchFamily="34" charset="0"/>
+                <a:ea typeface="Calibri" pitchFamily="34" charset="-122"/>
+                <a:cs typeface="Calibri" pitchFamily="34" charset="-120"/>
+              </a:rPr>
+              <a:t>6</a:t>
+            </a:r>
+            <a:endParaRPr lang="en-US" sz="1300" dirty="0"/>
+          </a:p>
+        </p:txBody>
+      </p:sp>
+      <p:sp>
+        <p:nvSpPr>
+          <p:cNvPr id="27" name="Text 25"/>
+          <p:cNvSpPr/>
+          <p:nvPr/>
+        </p:nvSpPr>
+        <p:spPr>
+          <a:xfrm>
+            <a:off x="5230368" y="3090672"/>
+            <a:ext cx="3401568" cy="685800"/>
+          </a:xfrm>
+          <a:prstGeom prst="rect">
+            <a:avLst/>
+          </a:prstGeom>
+          <a:noFill/>
+          <a:ln/>
+        </p:spPr>
+        <p:txBody>
+          <a:bodyPr wrap="square" lIns="0" tIns="0" rIns="0" bIns="0" rtlCol="0" anchor="t"/>
+          <a:lstStyle/>
+          <a:p>
+            <a:pPr indent="0" marL="0">
+              <a:lnSpc>
+                <a:spcPct val="105000"/>
+              </a:lnSpc>
+              <a:buNone/>
+            </a:pPr>
+            <a:r>
+              <a:rPr lang="en-US" sz="950" b="1" dirty="0">
+                <a:solidFill>
+                  <a:srgbClr val="1E2761"/>
+                </a:solidFill>
+                <a:latin typeface="Courier New" pitchFamily="34" charset="0"/>
+                <a:ea typeface="Courier New" pitchFamily="34" charset="-122"/>
+                <a:cs typeface="Courier New" pitchFamily="34" charset="-120"/>
+              </a:rPr>
+              <a:t>hypot(a**2 + b**2)</a:t>
+            </a:r>
+            <a:endParaRPr lang="en-US" sz="950" dirty="0"/>
+          </a:p>
+          <a:p>
+            <a:pPr indent="0" marL="0">
+              <a:lnSpc>
+                <a:spcPct val="105000"/>
+              </a:lnSpc>
+              <a:buNone/>
+            </a:pPr>
+            <a:r>
+              <a:rPr lang="en-US" sz="900" dirty="0">
+                <a:solidFill>
+                  <a:srgbClr val="2A3550"/>
+                </a:solidFill>
+                <a:latin typeface="Calibri" pitchFamily="34" charset="0"/>
+                <a:ea typeface="Calibri" pitchFamily="34" charset="-122"/>
+                <a:cs typeface="Calibri" pitchFamily="34" charset="-120"/>
+              </a:rPr>
+              <a:t>hypoténuse de 767 km — vérifier la SIGNATURE (fonction?) (day1)</a:t>
+            </a:r>
+            <a:endParaRPr lang="en-US" sz="950" dirty="0"/>
+          </a:p>
+        </p:txBody>
+      </p:sp>
+      <p:sp>
+        <p:nvSpPr>
+          <p:cNvPr id="28" name="Shape 26"/>
+          <p:cNvSpPr/>
+          <p:nvPr/>
+        </p:nvSpPr>
+        <p:spPr>
+          <a:xfrm>
+            <a:off x="457200" y="3931920"/>
+            <a:ext cx="4041648" cy="804672"/>
+          </a:xfrm>
+          <a:prstGeom prst="roundRect">
+            <a:avLst>
+              <a:gd name="adj" fmla="val 6818"/>
+            </a:avLst>
+          </a:prstGeom>
+          <a:solidFill>
+            <a:srgbClr val="EEF4FE"/>
+          </a:solidFill>
+          <a:ln/>
+          <a:effectLst>
+            <a:outerShdw sx="100000" sy="100000" kx="0" ky="0" algn="bl" rotWithShape="0" blurRad="88900" dist="25400" dir="2700000">
+              <a:srgbClr val="000000">
+                <a:alpha val="14000"/>
+              </a:srgbClr>
+            </a:outerShdw>
+          </a:effectLst>
+        </p:spPr>
+      </p:sp>
+      <p:sp>
+        <p:nvSpPr>
+          <p:cNvPr id="29" name="Shape 27"/>
+          <p:cNvSpPr/>
+          <p:nvPr/>
+        </p:nvSpPr>
+        <p:spPr>
+          <a:xfrm>
+            <a:off x="566928" y="4169664"/>
+            <a:ext cx="329184" cy="329184"/>
+          </a:xfrm>
+          <a:prstGeom prst="ellipse">
+            <a:avLst/>
+          </a:prstGeom>
+          <a:solidFill>
+            <a:srgbClr val="D64550"/>
+          </a:solidFill>
+          <a:ln/>
+        </p:spPr>
+      </p:sp>
+      <p:sp>
+        <p:nvSpPr>
+          <p:cNvPr id="30" name="Text 28"/>
+          <p:cNvSpPr/>
+          <p:nvPr/>
+        </p:nvSpPr>
+        <p:spPr>
+          <a:xfrm>
+            <a:off x="566928" y="4160520"/>
+            <a:ext cx="329184" cy="329184"/>
+          </a:xfrm>
+          <a:prstGeom prst="rect">
+            <a:avLst/>
+          </a:prstGeom>
+          <a:noFill/>
+          <a:ln/>
+        </p:spPr>
+        <p:txBody>
+          <a:bodyPr wrap="square" lIns="0" tIns="0" rIns="0" bIns="0" rtlCol="0" anchor="ctr"/>
+          <a:lstStyle/>
+          <a:p>
+            <a:pPr algn="ctr" indent="0" marL="0">
+              <a:buNone/>
+            </a:pPr>
+            <a:r>
+              <a:rPr lang="en-US" sz="1300" b="1" dirty="0">
+                <a:solidFill>
+                  <a:srgbClr val="FFFFFF"/>
+                </a:solidFill>
+                <a:latin typeface="Calibri" pitchFamily="34" charset="0"/>
+                <a:ea typeface="Calibri" pitchFamily="34" charset="-122"/>
+                <a:cs typeface="Calibri" pitchFamily="34" charset="-120"/>
+              </a:rPr>
+              <a:t>7</a:t>
+            </a:r>
+            <a:endParaRPr lang="en-US" sz="1300" dirty="0"/>
+          </a:p>
+        </p:txBody>
+      </p:sp>
+      <p:sp>
+        <p:nvSpPr>
+          <p:cNvPr id="31" name="Text 29"/>
+          <p:cNvSpPr/>
+          <p:nvPr/>
+        </p:nvSpPr>
+        <p:spPr>
+          <a:xfrm>
+            <a:off x="1005840" y="4005072"/>
+            <a:ext cx="3401568" cy="685800"/>
+          </a:xfrm>
+          <a:prstGeom prst="rect">
+            <a:avLst/>
+          </a:prstGeom>
+          <a:noFill/>
+          <a:ln/>
+        </p:spPr>
+        <p:txBody>
+          <a:bodyPr wrap="square" lIns="0" tIns="0" rIns="0" bIns="0" rtlCol="0" anchor="t"/>
+          <a:lstStyle/>
+          <a:p>
+            <a:pPr indent="0" marL="0">
+              <a:lnSpc>
+                <a:spcPct val="105000"/>
+              </a:lnSpc>
+              <a:buNone/>
+            </a:pPr>
+            <a:r>
+              <a:rPr lang="en-US" sz="950" b="1" dirty="0">
+                <a:solidFill>
+                  <a:srgbClr val="1E2761"/>
+                </a:solidFill>
+                <a:latin typeface="Courier New" pitchFamily="34" charset="0"/>
+                <a:ea typeface="Courier New" pitchFamily="34" charset="-122"/>
+                <a:cs typeface="Courier New" pitchFamily="34" charset="-120"/>
+              </a:rPr>
+              <a:t>Accuracy 84 % sur du 85/15</a:t>
+            </a:r>
+            <a:endParaRPr lang="en-US" sz="950" dirty="0"/>
+          </a:p>
+          <a:p>
+            <a:pPr indent="0" marL="0">
+              <a:lnSpc>
+                <a:spcPct val="105000"/>
+              </a:lnSpc>
+              <a:buNone/>
+            </a:pPr>
+            <a:r>
+              <a:rPr lang="en-US" sz="900" dirty="0">
+                <a:solidFill>
+                  <a:srgbClr val="2A3550"/>
+                </a:solidFill>
+                <a:latin typeface="Calibri" pitchFamily="34" charset="0"/>
+                <a:ea typeface="Calibri" pitchFamily="34" charset="-122"/>
+                <a:cs typeface="Calibri" pitchFamily="34" charset="-120"/>
+              </a:rPr>
+              <a:t>pire que l'idiot « toujours Deny » — baseline d'abord ! (S3_P1)</a:t>
+            </a:r>
+            <a:endParaRPr lang="en-US" sz="950" dirty="0"/>
+          </a:p>
+        </p:txBody>
+      </p:sp>
+      <p:sp>
+        <p:nvSpPr>
+          <p:cNvPr id="32" name="Shape 30"/>
+          <p:cNvSpPr/>
+          <p:nvPr/>
+        </p:nvSpPr>
+        <p:spPr>
+          <a:xfrm>
+            <a:off x="4681728" y="3931920"/>
+            <a:ext cx="4041648" cy="804672"/>
+          </a:xfrm>
+          <a:prstGeom prst="roundRect">
+            <a:avLst>
+              <a:gd name="adj" fmla="val 6818"/>
+            </a:avLst>
+          </a:prstGeom>
+          <a:solidFill>
+            <a:srgbClr val="EEF4FE"/>
+          </a:solidFill>
+          <a:ln/>
+          <a:effectLst>
+            <a:outerShdw sx="100000" sy="100000" kx="0" ky="0" algn="bl" rotWithShape="0" blurRad="88900" dist="25400" dir="2700000">
+              <a:srgbClr val="000000">
+                <a:alpha val="14000"/>
+              </a:srgbClr>
+            </a:outerShdw>
+          </a:effectLst>
+        </p:spPr>
+      </p:sp>
+      <p:sp>
+        <p:nvSpPr>
+          <p:cNvPr id="33" name="Shape 31"/>
+          <p:cNvSpPr/>
+          <p:nvPr/>
+        </p:nvSpPr>
+        <p:spPr>
+          <a:xfrm>
+            <a:off x="4791456" y="4169664"/>
+            <a:ext cx="329184" cy="329184"/>
+          </a:xfrm>
+          <a:prstGeom prst="ellipse">
+            <a:avLst/>
+          </a:prstGeom>
+          <a:solidFill>
+            <a:srgbClr val="D64550"/>
+          </a:solidFill>
+          <a:ln/>
+        </p:spPr>
+      </p:sp>
+      <p:sp>
+        <p:nvSpPr>
+          <p:cNvPr id="34" name="Text 32"/>
+          <p:cNvSpPr/>
+          <p:nvPr/>
+        </p:nvSpPr>
+        <p:spPr>
+          <a:xfrm>
+            <a:off x="4791456" y="4160520"/>
+            <a:ext cx="329184" cy="329184"/>
+          </a:xfrm>
+          <a:prstGeom prst="rect">
+            <a:avLst/>
+          </a:prstGeom>
+          <a:noFill/>
+          <a:ln/>
+        </p:spPr>
+        <p:txBody>
+          <a:bodyPr wrap="square" lIns="0" tIns="0" rIns="0" bIns="0" rtlCol="0" anchor="ctr"/>
+          <a:lstStyle/>
+          <a:p>
+            <a:pPr algn="ctr" indent="0" marL="0">
+              <a:buNone/>
+            </a:pPr>
+            <a:r>
+              <a:rPr lang="en-US" sz="1300" b="1" dirty="0">
+                <a:solidFill>
+                  <a:srgbClr val="FFFFFF"/>
+                </a:solidFill>
+                <a:latin typeface="Calibri" pitchFamily="34" charset="0"/>
+                <a:ea typeface="Calibri" pitchFamily="34" charset="-122"/>
+                <a:cs typeface="Calibri" pitchFamily="34" charset="-120"/>
+              </a:rPr>
+              <a:t>8</a:t>
+            </a:r>
+            <a:endParaRPr lang="en-US" sz="1300" dirty="0"/>
+          </a:p>
+        </p:txBody>
+      </p:sp>
+      <p:sp>
+        <p:nvSpPr>
+          <p:cNvPr id="35" name="Text 33"/>
+          <p:cNvSpPr/>
+          <p:nvPr/>
+        </p:nvSpPr>
+        <p:spPr>
+          <a:xfrm>
+            <a:off x="5230368" y="4005072"/>
+            <a:ext cx="3401568" cy="685800"/>
+          </a:xfrm>
+          <a:prstGeom prst="rect">
+            <a:avLst/>
+          </a:prstGeom>
+          <a:noFill/>
+          <a:ln/>
+        </p:spPr>
+        <p:txBody>
+          <a:bodyPr wrap="square" lIns="0" tIns="0" rIns="0" bIns="0" rtlCol="0" anchor="t"/>
+          <a:lstStyle/>
+          <a:p>
+            <a:pPr indent="0" marL="0">
+              <a:lnSpc>
+                <a:spcPct val="105000"/>
+              </a:lnSpc>
+              <a:buNone/>
+            </a:pPr>
+            <a:r>
+              <a:rPr lang="en-US" sz="950" b="1" dirty="0">
+                <a:solidFill>
+                  <a:srgbClr val="1E2761"/>
+                </a:solidFill>
+                <a:latin typeface="Courier New" pitchFamily="34" charset="0"/>
+                <a:ea typeface="Courier New" pitchFamily="34" charset="-122"/>
+                <a:cs typeface="Courier New" pitchFamily="34" charset="-120"/>
+              </a:rPr>
+              <a:t>idxmin() → indice, pas valeur</a:t>
+            </a:r>
+            <a:endParaRPr lang="en-US" sz="950" dirty="0"/>
+          </a:p>
+          <a:p>
+            <a:pPr indent="0" marL="0">
+              <a:lnSpc>
+                <a:spcPct val="105000"/>
+              </a:lnSpc>
+              <a:buNone/>
+            </a:pPr>
+            <a:r>
+              <a:rPr lang="en-US" sz="900" dirty="0">
+                <a:solidFill>
+                  <a:srgbClr val="2A3550"/>
+                </a:solidFill>
+                <a:latin typeface="Calibri" pitchFamily="34" charset="0"/>
+                <a:ea typeface="Calibri" pitchFamily="34" charset="-122"/>
+                <a:cs typeface="Calibri" pitchFamily="34" charset="-120"/>
+              </a:rPr>
+              <a:t>ligne 2 = k 3 : le meilleur k n'était pas 2 ! (S4_P1)</a:t>
+            </a:r>
+            <a:endParaRPr lang="en-US" sz="950" dirty="0"/>
+          </a:p>
+        </p:txBody>
+      </p:sp>
+    </p:spTree>
+  </p:cSld>
+  <p:clrMapOvr>
+    <a:masterClrMapping/>
+  </p:clrMapOvr>
+</p:sld>
+</file>
+
+<file path=ppt/slides/slide43.xml><?xml version="1.0" encoding="utf-8"?>
+<p:sld xmlns:a="http://schemas.openxmlformats.org/drawingml/2006/main" xmlns:r="http://schemas.openxmlformats.org/officeDocument/2006/relationships" xmlns:p="http://schemas.openxmlformats.org/presentationml/2006/main">
+  <p:cSld name="Slide 43">
     <p:bg>
       <p:bgPr>
         <a:solidFill>
@@ -39820,7 +41973,7 @@
                 <a:ea typeface="Calibri" pitchFamily="34" charset="-122"/>
                 <a:cs typeface="Calibri" pitchFamily="34" charset="-120"/>
               </a:rPr>
-              <a:t>KNN · Naive Bayes · arbres · forêts</a:t>
+              <a:t>KNN · NB · arbres · forêts · boosting · clustering</a:t>
             </a:r>
             <a:endParaRPr lang="en-US" sz="1100" dirty="0"/>
           </a:p>

</xml_diff>